<commit_message>
Theorie applied + heatmap
</commit_message>
<xml_diff>
--- a/gen_ai_robot_pendulum.pptx
+++ b/gen_ai_robot_pendulum.pptx
@@ -4,6 +4,14 @@
   <p:sldMasterIdLst>
     <p:sldMasterId id="2147483648" r:id="rId1"/>
   </p:sldMasterIdLst>
+  <p:sldIdLst>
+    <p:sldId id="256" r:id="rId2"/>
+    <p:sldId id="257" r:id="rId3"/>
+    <p:sldId id="258" r:id="rId4"/>
+    <p:sldId id="259" r:id="rId5"/>
+    <p:sldId id="260" r:id="rId6"/>
+    <p:sldId id="261" r:id="rId7"/>
+  </p:sldIdLst>
   <p:sldSz cx="9144000" cy="6858000" type="screen4x3"/>
   <p:notesSz cx="6858000" cy="9144000"/>
   <p:defaultTextStyle>
@@ -285,7 +293,8 @@
           <a:p>
             <a:fld id="{AA309A6D-C09C-4548-B29A-6CF363A7E532}" type="datetimeFigureOut">
               <a:rPr lang="fr-FR" smtClean="0"/>
-              <a:t>26/09/2006</a:t>
+              <a:pPr/>
+              <a:t>16/06/2026</a:t>
             </a:fld>
             <a:endParaRPr lang="fr-BE"/>
           </a:p>
@@ -327,6 +336,7 @@
           <a:p>
             <a:fld id="{CF4668DC-857F-487D-BFFA-8C0CA5037977}" type="slidenum">
               <a:rPr lang="fr-BE" smtClean="0"/>
+              <a:pPr/>
               <a:t>‹N°›</a:t>
             </a:fld>
             <a:endParaRPr lang="fr-BE"/>
@@ -450,7 +460,8 @@
           <a:p>
             <a:fld id="{AA309A6D-C09C-4548-B29A-6CF363A7E532}" type="datetimeFigureOut">
               <a:rPr lang="fr-FR" smtClean="0"/>
-              <a:t>26/09/2006</a:t>
+              <a:pPr/>
+              <a:t>16/06/2026</a:t>
             </a:fld>
             <a:endParaRPr lang="fr-BE"/>
           </a:p>
@@ -492,6 +503,7 @@
           <a:p>
             <a:fld id="{CF4668DC-857F-487D-BFFA-8C0CA5037977}" type="slidenum">
               <a:rPr lang="fr-BE" smtClean="0"/>
+              <a:pPr/>
               <a:t>‹N°›</a:t>
             </a:fld>
             <a:endParaRPr lang="fr-BE"/>
@@ -625,7 +637,8 @@
           <a:p>
             <a:fld id="{AA309A6D-C09C-4548-B29A-6CF363A7E532}" type="datetimeFigureOut">
               <a:rPr lang="fr-FR" smtClean="0"/>
-              <a:t>26/09/2006</a:t>
+              <a:pPr/>
+              <a:t>16/06/2026</a:t>
             </a:fld>
             <a:endParaRPr lang="fr-BE"/>
           </a:p>
@@ -667,6 +680,7 @@
           <a:p>
             <a:fld id="{CF4668DC-857F-487D-BFFA-8C0CA5037977}" type="slidenum">
               <a:rPr lang="fr-BE" smtClean="0"/>
+              <a:pPr/>
               <a:t>‹N°›</a:t>
             </a:fld>
             <a:endParaRPr lang="fr-BE"/>
@@ -790,7 +804,8 @@
           <a:p>
             <a:fld id="{AA309A6D-C09C-4548-B29A-6CF363A7E532}" type="datetimeFigureOut">
               <a:rPr lang="fr-FR" smtClean="0"/>
-              <a:t>26/09/2006</a:t>
+              <a:pPr/>
+              <a:t>16/06/2026</a:t>
             </a:fld>
             <a:endParaRPr lang="fr-BE"/>
           </a:p>
@@ -832,6 +847,7 @@
           <a:p>
             <a:fld id="{CF4668DC-857F-487D-BFFA-8C0CA5037977}" type="slidenum">
               <a:rPr lang="fr-BE" smtClean="0"/>
+              <a:pPr/>
               <a:t>‹N°›</a:t>
             </a:fld>
             <a:endParaRPr lang="fr-BE"/>
@@ -1031,7 +1047,8 @@
           <a:p>
             <a:fld id="{AA309A6D-C09C-4548-B29A-6CF363A7E532}" type="datetimeFigureOut">
               <a:rPr lang="fr-FR" smtClean="0"/>
-              <a:t>26/09/2006</a:t>
+              <a:pPr/>
+              <a:t>16/06/2026</a:t>
             </a:fld>
             <a:endParaRPr lang="fr-BE"/>
           </a:p>
@@ -1073,6 +1090,7 @@
           <a:p>
             <a:fld id="{CF4668DC-857F-487D-BFFA-8C0CA5037977}" type="slidenum">
               <a:rPr lang="fr-BE" smtClean="0"/>
+              <a:pPr/>
               <a:t>‹N°›</a:t>
             </a:fld>
             <a:endParaRPr lang="fr-BE"/>
@@ -1314,7 +1332,8 @@
           <a:p>
             <a:fld id="{AA309A6D-C09C-4548-B29A-6CF363A7E532}" type="datetimeFigureOut">
               <a:rPr lang="fr-FR" smtClean="0"/>
-              <a:t>26/09/2006</a:t>
+              <a:pPr/>
+              <a:t>16/06/2026</a:t>
             </a:fld>
             <a:endParaRPr lang="fr-BE"/>
           </a:p>
@@ -1356,6 +1375,7 @@
           <a:p>
             <a:fld id="{CF4668DC-857F-487D-BFFA-8C0CA5037977}" type="slidenum">
               <a:rPr lang="fr-BE" smtClean="0"/>
+              <a:pPr/>
               <a:t>‹N°›</a:t>
             </a:fld>
             <a:endParaRPr lang="fr-BE"/>
@@ -1731,7 +1751,8 @@
           <a:p>
             <a:fld id="{AA309A6D-C09C-4548-B29A-6CF363A7E532}" type="datetimeFigureOut">
               <a:rPr lang="fr-FR" smtClean="0"/>
-              <a:t>26/09/2006</a:t>
+              <a:pPr/>
+              <a:t>16/06/2026</a:t>
             </a:fld>
             <a:endParaRPr lang="fr-BE"/>
           </a:p>
@@ -1773,6 +1794,7 @@
           <a:p>
             <a:fld id="{CF4668DC-857F-487D-BFFA-8C0CA5037977}" type="slidenum">
               <a:rPr lang="fr-BE" smtClean="0"/>
+              <a:pPr/>
               <a:t>‹N°›</a:t>
             </a:fld>
             <a:endParaRPr lang="fr-BE"/>
@@ -1844,7 +1866,8 @@
           <a:p>
             <a:fld id="{AA309A6D-C09C-4548-B29A-6CF363A7E532}" type="datetimeFigureOut">
               <a:rPr lang="fr-FR" smtClean="0"/>
-              <a:t>26/09/2006</a:t>
+              <a:pPr/>
+              <a:t>16/06/2026</a:t>
             </a:fld>
             <a:endParaRPr lang="fr-BE"/>
           </a:p>
@@ -1886,6 +1909,7 @@
           <a:p>
             <a:fld id="{CF4668DC-857F-487D-BFFA-8C0CA5037977}" type="slidenum">
               <a:rPr lang="fr-BE" smtClean="0"/>
+              <a:pPr/>
               <a:t>‹N°›</a:t>
             </a:fld>
             <a:endParaRPr lang="fr-BE"/>
@@ -1934,7 +1958,8 @@
           <a:p>
             <a:fld id="{AA309A6D-C09C-4548-B29A-6CF363A7E532}" type="datetimeFigureOut">
               <a:rPr lang="fr-FR" smtClean="0"/>
-              <a:t>26/09/2006</a:t>
+              <a:pPr/>
+              <a:t>16/06/2026</a:t>
             </a:fld>
             <a:endParaRPr lang="fr-BE"/>
           </a:p>
@@ -1976,6 +2001,7 @@
           <a:p>
             <a:fld id="{CF4668DC-857F-487D-BFFA-8C0CA5037977}" type="slidenum">
               <a:rPr lang="fr-BE" smtClean="0"/>
+              <a:pPr/>
               <a:t>‹N°›</a:t>
             </a:fld>
             <a:endParaRPr lang="fr-BE"/>
@@ -2206,7 +2232,8 @@
           <a:p>
             <a:fld id="{AA309A6D-C09C-4548-B29A-6CF363A7E532}" type="datetimeFigureOut">
               <a:rPr lang="fr-FR" smtClean="0"/>
-              <a:t>26/09/2006</a:t>
+              <a:pPr/>
+              <a:t>16/06/2026</a:t>
             </a:fld>
             <a:endParaRPr lang="fr-BE"/>
           </a:p>
@@ -2248,6 +2275,7 @@
           <a:p>
             <a:fld id="{CF4668DC-857F-487D-BFFA-8C0CA5037977}" type="slidenum">
               <a:rPr lang="fr-BE" smtClean="0"/>
+              <a:pPr/>
               <a:t>‹N°›</a:t>
             </a:fld>
             <a:endParaRPr lang="fr-BE"/>
@@ -2454,7 +2482,8 @@
           <a:p>
             <a:fld id="{AA309A6D-C09C-4548-B29A-6CF363A7E532}" type="datetimeFigureOut">
               <a:rPr lang="fr-FR" smtClean="0"/>
-              <a:t>26/09/2006</a:t>
+              <a:pPr/>
+              <a:t>16/06/2026</a:t>
             </a:fld>
             <a:endParaRPr lang="fr-BE"/>
           </a:p>
@@ -2496,6 +2525,7 @@
           <a:p>
             <a:fld id="{CF4668DC-857F-487D-BFFA-8C0CA5037977}" type="slidenum">
               <a:rPr lang="fr-BE" smtClean="0"/>
+              <a:pPr/>
               <a:t>‹N°›</a:t>
             </a:fld>
             <a:endParaRPr lang="fr-BE"/>
@@ -2662,7 +2692,8 @@
           <a:p>
             <a:fld id="{AA309A6D-C09C-4548-B29A-6CF363A7E532}" type="datetimeFigureOut">
               <a:rPr lang="fr-FR" smtClean="0"/>
-              <a:t>26/09/2006</a:t>
+              <a:pPr/>
+              <a:t>16/06/2026</a:t>
             </a:fld>
             <a:endParaRPr lang="fr-BE"/>
           </a:p>
@@ -2740,6 +2771,7 @@
           <a:p>
             <a:fld id="{CF4668DC-857F-487D-BFFA-8C0CA5037977}" type="slidenum">
               <a:rPr lang="fr-BE" smtClean="0"/>
+              <a:pPr/>
               <a:t>‹N°›</a:t>
             </a:fld>
             <a:endParaRPr lang="fr-BE"/>
@@ -3013,6 +3045,2329 @@
     </p:otherStyle>
   </p:txStyles>
 </p:sldMaster>
+</file>
+
+<file path=ppt/slides/slide1.xml><?xml version="1.0" encoding="utf-8"?>
+<p:sld xmlns:a="http://schemas.openxmlformats.org/drawingml/2006/main" xmlns:r="http://schemas.openxmlformats.org/officeDocument/2006/relationships" xmlns:p="http://schemas.openxmlformats.org/presentationml/2006/main">
+  <p:cSld>
+    <p:spTree>
+      <p:nvGrpSpPr>
+        <p:cNvPr id="1" name=""/>
+        <p:cNvGrpSpPr/>
+        <p:nvPr/>
+      </p:nvGrpSpPr>
+      <p:grpSpPr>
+        <a:xfrm>
+          <a:off x="0" y="0"/>
+          <a:ext cx="0" cy="0"/>
+          <a:chOff x="0" y="0"/>
+          <a:chExt cx="0" cy="0"/>
+        </a:xfrm>
+      </p:grpSpPr>
+      <p:sp>
+        <p:nvSpPr>
+          <p:cNvPr id="2" name="Titre 1"/>
+          <p:cNvSpPr>
+            <a:spLocks noGrp="1"/>
+          </p:cNvSpPr>
+          <p:nvPr>
+            <p:ph type="title"/>
+          </p:nvPr>
+        </p:nvSpPr>
+        <p:spPr>
+          <a:xfrm>
+            <a:off x="457200" y="39762"/>
+            <a:ext cx="8229600" cy="436910"/>
+          </a:xfrm>
+        </p:spPr>
+        <p:txBody>
+          <a:bodyPr>
+            <a:normAutofit fontScale="90000"/>
+          </a:bodyPr>
+          <a:lstStyle/>
+          <a:p>
+            <a:r>
+              <a:rPr lang="fr-FR" dirty="0" smtClean="0"/>
+              <a:t>Robot inverse </a:t>
+            </a:r>
+            <a:r>
+              <a:rPr lang="fr-FR" dirty="0" err="1" smtClean="0"/>
+              <a:t>pendulum</a:t>
+            </a:r>
+            <a:endParaRPr lang="fr-FR" dirty="0"/>
+          </a:p>
+        </p:txBody>
+      </p:sp>
+      <p:graphicFrame>
+        <p:nvGraphicFramePr>
+          <p:cNvPr id="4" name="Espace réservé du contenu 3"/>
+          <p:cNvGraphicFramePr>
+            <a:graphicFrameLocks noGrp="1"/>
+          </p:cNvGraphicFramePr>
+          <p:nvPr>
+            <p:ph idx="1"/>
+          </p:nvPr>
+        </p:nvGraphicFramePr>
+        <p:xfrm>
+          <a:off x="0" y="548680"/>
+          <a:ext cx="9144000" cy="6598920"/>
+        </p:xfrm>
+        <a:graphic>
+          <a:graphicData uri="http://schemas.openxmlformats.org/drawingml/2006/table">
+            <a:tbl>
+              <a:tblPr firstRow="1" bandRow="1">
+                <a:tableStyleId>{5C22544A-7EE6-4342-B048-85BDC9FD1C3A}</a:tableStyleId>
+              </a:tblPr>
+              <a:tblGrid>
+                <a:gridCol w="3261805"/>
+                <a:gridCol w="696576"/>
+                <a:gridCol w="5185619"/>
+              </a:tblGrid>
+              <a:tr h="370840">
+                <a:tc>
+                  <a:txBody>
+                    <a:bodyPr/>
+                    <a:lstStyle/>
+                    <a:p>
+                      <a:endParaRPr lang="fr-FR" dirty="0"/>
+                    </a:p>
+                  </a:txBody>
+                  <a:tcPr/>
+                </a:tc>
+                <a:tc>
+                  <a:txBody>
+                    <a:bodyPr/>
+                    <a:lstStyle/>
+                    <a:p>
+                      <a:endParaRPr lang="fr-FR" dirty="0"/>
+                    </a:p>
+                  </a:txBody>
+                  <a:tcPr/>
+                </a:tc>
+                <a:tc>
+                  <a:txBody>
+                    <a:bodyPr/>
+                    <a:lstStyle/>
+                    <a:p>
+                      <a:endParaRPr lang="fr-FR" dirty="0"/>
+                    </a:p>
+                  </a:txBody>
+                  <a:tcPr/>
+                </a:tc>
+              </a:tr>
+              <a:tr h="370840">
+                <a:tc>
+                  <a:txBody>
+                    <a:bodyPr/>
+                    <a:lstStyle/>
+                    <a:p>
+                      <a:r>
+                        <a:rPr lang="fr-FR" dirty="0" err="1" smtClean="0"/>
+                        <a:t>Requirements</a:t>
+                      </a:r>
+                      <a:r>
+                        <a:rPr lang="fr-FR" dirty="0" smtClean="0"/>
+                        <a:t> management</a:t>
+                      </a:r>
+                      <a:endParaRPr lang="fr-FR" dirty="0"/>
+                    </a:p>
+                  </a:txBody>
+                  <a:tcPr/>
+                </a:tc>
+                <a:tc>
+                  <a:txBody>
+                    <a:bodyPr/>
+                    <a:lstStyle/>
+                    <a:p>
+                      <a:r>
+                        <a:rPr lang="fr-FR" dirty="0" smtClean="0"/>
+                        <a:t>5/5</a:t>
+                      </a:r>
+                      <a:endParaRPr lang="fr-FR" dirty="0"/>
+                    </a:p>
+                  </a:txBody>
+                  <a:tcPr/>
+                </a:tc>
+                <a:tc>
+                  <a:txBody>
+                    <a:bodyPr/>
+                    <a:lstStyle/>
+                    <a:p>
+                      <a:r>
+                        <a:rPr lang="fr-FR" dirty="0" err="1" smtClean="0"/>
+                        <a:t>Perfectly</a:t>
+                      </a:r>
+                      <a:r>
+                        <a:rPr lang="fr-FR" dirty="0" smtClean="0"/>
+                        <a:t> </a:t>
+                      </a:r>
+                      <a:r>
+                        <a:rPr lang="fr-FR" dirty="0" err="1" smtClean="0"/>
+                        <a:t>understand</a:t>
+                      </a:r>
+                      <a:r>
+                        <a:rPr lang="fr-FR" dirty="0" smtClean="0"/>
+                        <a:t> the content of the robot and propose </a:t>
+                      </a:r>
+                      <a:r>
+                        <a:rPr lang="fr-FR" dirty="0" err="1" smtClean="0"/>
+                        <a:t>something</a:t>
+                      </a:r>
+                      <a:r>
+                        <a:rPr lang="fr-FR" dirty="0" smtClean="0"/>
+                        <a:t> </a:t>
+                      </a:r>
+                      <a:r>
+                        <a:rPr lang="fr-FR" dirty="0" err="1" smtClean="0"/>
+                        <a:t>adequate</a:t>
+                      </a:r>
+                      <a:endParaRPr lang="fr-FR" dirty="0"/>
+                    </a:p>
+                  </a:txBody>
+                  <a:tcPr/>
+                </a:tc>
+              </a:tr>
+              <a:tr h="370840">
+                <a:tc>
+                  <a:txBody>
+                    <a:bodyPr/>
+                    <a:lstStyle/>
+                    <a:p>
+                      <a:r>
+                        <a:rPr lang="fr-FR" dirty="0" smtClean="0"/>
+                        <a:t>System </a:t>
+                      </a:r>
+                      <a:r>
+                        <a:rPr lang="fr-FR" dirty="0" err="1" smtClean="0"/>
+                        <a:t>view</a:t>
+                      </a:r>
+                      <a:endParaRPr lang="fr-FR" dirty="0"/>
+                    </a:p>
+                  </a:txBody>
+                  <a:tcPr/>
+                </a:tc>
+                <a:tc>
+                  <a:txBody>
+                    <a:bodyPr/>
+                    <a:lstStyle/>
+                    <a:p>
+                      <a:r>
+                        <a:rPr lang="fr-FR" dirty="0" smtClean="0"/>
+                        <a:t>5/5</a:t>
+                      </a:r>
+                      <a:endParaRPr lang="fr-FR" dirty="0"/>
+                    </a:p>
+                  </a:txBody>
+                  <a:tcPr/>
+                </a:tc>
+                <a:tc>
+                  <a:txBody>
+                    <a:bodyPr/>
+                    <a:lstStyle/>
+                    <a:p>
+                      <a:r>
+                        <a:rPr lang="fr-FR" dirty="0" err="1" smtClean="0"/>
+                        <a:t>Perfectly</a:t>
+                      </a:r>
+                      <a:r>
+                        <a:rPr lang="fr-FR" dirty="0" smtClean="0"/>
+                        <a:t> </a:t>
+                      </a:r>
+                      <a:r>
+                        <a:rPr lang="fr-FR" dirty="0" err="1" smtClean="0"/>
+                        <a:t>understand</a:t>
+                      </a:r>
+                      <a:r>
+                        <a:rPr lang="fr-FR" dirty="0" smtClean="0"/>
+                        <a:t> the DK + </a:t>
+                      </a:r>
+                      <a:r>
+                        <a:rPr lang="fr-FR" dirty="0" err="1" smtClean="0"/>
+                        <a:t>motor</a:t>
+                      </a:r>
+                      <a:r>
+                        <a:rPr lang="fr-FR" dirty="0" smtClean="0"/>
+                        <a:t> control + </a:t>
+                      </a:r>
+                      <a:r>
+                        <a:rPr lang="fr-FR" dirty="0" err="1" smtClean="0"/>
+                        <a:t>motors</a:t>
+                      </a:r>
+                      <a:r>
+                        <a:rPr lang="fr-FR" dirty="0" smtClean="0"/>
+                        <a:t>/</a:t>
+                      </a:r>
+                      <a:r>
+                        <a:rPr lang="fr-FR" dirty="0" err="1" smtClean="0"/>
+                        <a:t>encoders</a:t>
+                      </a:r>
+                      <a:r>
+                        <a:rPr lang="fr-FR" dirty="0" smtClean="0"/>
+                        <a:t> and </a:t>
+                      </a:r>
+                      <a:r>
+                        <a:rPr lang="fr-FR" dirty="0" err="1" smtClean="0"/>
+                        <a:t>provide</a:t>
+                      </a:r>
+                      <a:r>
+                        <a:rPr lang="fr-FR" dirty="0" smtClean="0"/>
+                        <a:t> </a:t>
+                      </a:r>
+                      <a:r>
+                        <a:rPr lang="fr-FR" dirty="0" err="1" smtClean="0"/>
+                        <a:t>high</a:t>
+                      </a:r>
+                      <a:r>
+                        <a:rPr lang="fr-FR" dirty="0" smtClean="0"/>
+                        <a:t> </a:t>
+                      </a:r>
+                      <a:r>
+                        <a:rPr lang="fr-FR" dirty="0" err="1" smtClean="0"/>
+                        <a:t>level</a:t>
+                      </a:r>
+                      <a:r>
+                        <a:rPr lang="fr-FR" dirty="0" smtClean="0"/>
+                        <a:t> </a:t>
+                      </a:r>
+                      <a:r>
+                        <a:rPr lang="fr-FR" dirty="0" err="1" smtClean="0"/>
+                        <a:t>view</a:t>
+                      </a:r>
+                      <a:endParaRPr lang="fr-FR" dirty="0"/>
+                    </a:p>
+                  </a:txBody>
+                  <a:tcPr/>
+                </a:tc>
+              </a:tr>
+              <a:tr h="370840">
+                <a:tc>
+                  <a:txBody>
+                    <a:bodyPr/>
+                    <a:lstStyle/>
+                    <a:p>
+                      <a:r>
+                        <a:rPr lang="fr-FR" dirty="0" err="1" smtClean="0"/>
+                        <a:t>Board</a:t>
+                      </a:r>
+                      <a:r>
+                        <a:rPr lang="fr-FR" dirty="0" smtClean="0"/>
+                        <a:t> interface</a:t>
+                      </a:r>
+                      <a:endParaRPr lang="fr-FR" dirty="0"/>
+                    </a:p>
+                  </a:txBody>
+                  <a:tcPr/>
+                </a:tc>
+                <a:tc>
+                  <a:txBody>
+                    <a:bodyPr/>
+                    <a:lstStyle/>
+                    <a:p>
+                      <a:r>
+                        <a:rPr lang="fr-FR" dirty="0" smtClean="0"/>
+                        <a:t>5/5</a:t>
+                      </a:r>
+                      <a:endParaRPr lang="fr-FR" dirty="0"/>
+                    </a:p>
+                  </a:txBody>
+                  <a:tcPr/>
+                </a:tc>
+                <a:tc>
+                  <a:txBody>
+                    <a:bodyPr/>
+                    <a:lstStyle/>
+                    <a:p>
+                      <a:r>
+                        <a:rPr lang="fr-FR" dirty="0" err="1" smtClean="0"/>
+                        <a:t>Mapped</a:t>
+                      </a:r>
+                      <a:r>
+                        <a:rPr lang="fr-FR" dirty="0" smtClean="0"/>
+                        <a:t> </a:t>
+                      </a:r>
+                      <a:r>
+                        <a:rPr lang="fr-FR" dirty="0" err="1" smtClean="0"/>
+                        <a:t>precisely</a:t>
+                      </a:r>
+                      <a:r>
+                        <a:rPr lang="fr-FR" dirty="0" smtClean="0"/>
+                        <a:t> the system </a:t>
+                      </a:r>
+                      <a:r>
+                        <a:rPr lang="fr-FR" dirty="0" err="1" smtClean="0"/>
+                        <a:t>view</a:t>
+                      </a:r>
+                      <a:r>
+                        <a:rPr lang="fr-FR" dirty="0" smtClean="0"/>
+                        <a:t> to </a:t>
+                      </a:r>
+                      <a:r>
+                        <a:rPr lang="fr-FR" dirty="0" err="1" smtClean="0"/>
+                        <a:t>signals</a:t>
+                      </a:r>
+                      <a:r>
+                        <a:rPr lang="fr-FR" dirty="0" smtClean="0"/>
+                        <a:t> of </a:t>
+                      </a:r>
+                      <a:r>
+                        <a:rPr lang="fr-FR" dirty="0" err="1" smtClean="0"/>
+                        <a:t>each</a:t>
+                      </a:r>
+                      <a:r>
+                        <a:rPr lang="fr-FR" dirty="0" smtClean="0"/>
+                        <a:t> </a:t>
+                      </a:r>
+                      <a:r>
+                        <a:rPr lang="fr-FR" dirty="0" err="1" smtClean="0"/>
+                        <a:t>boards</a:t>
+                      </a:r>
+                      <a:endParaRPr lang="fr-FR" dirty="0"/>
+                    </a:p>
+                  </a:txBody>
+                  <a:tcPr/>
+                </a:tc>
+              </a:tr>
+              <a:tr h="370840">
+                <a:tc>
+                  <a:txBody>
+                    <a:bodyPr/>
+                    <a:lstStyle/>
+                    <a:p>
+                      <a:r>
+                        <a:rPr lang="fr-FR" dirty="0" smtClean="0"/>
+                        <a:t>Pins allocation</a:t>
+                      </a:r>
+                      <a:endParaRPr lang="fr-FR" dirty="0"/>
+                    </a:p>
+                  </a:txBody>
+                  <a:tcPr/>
+                </a:tc>
+                <a:tc>
+                  <a:txBody>
+                    <a:bodyPr/>
+                    <a:lstStyle/>
+                    <a:p>
+                      <a:r>
+                        <a:rPr lang="fr-FR" dirty="0" smtClean="0"/>
+                        <a:t>7/5</a:t>
+                      </a:r>
+                      <a:endParaRPr lang="fr-FR" dirty="0"/>
+                    </a:p>
+                  </a:txBody>
+                  <a:tcPr/>
+                </a:tc>
+                <a:tc>
+                  <a:txBody>
+                    <a:bodyPr/>
+                    <a:lstStyle/>
+                    <a:p>
+                      <a:r>
+                        <a:rPr lang="fr-FR" dirty="0" err="1" smtClean="0"/>
+                        <a:t>Found</a:t>
+                      </a:r>
+                      <a:r>
+                        <a:rPr lang="fr-FR" dirty="0" smtClean="0"/>
+                        <a:t> a bug </a:t>
+                      </a:r>
+                      <a:r>
+                        <a:rPr lang="fr-FR" dirty="0" err="1" smtClean="0"/>
+                        <a:t>between</a:t>
+                      </a:r>
+                      <a:r>
+                        <a:rPr lang="fr-FR" dirty="0" smtClean="0"/>
+                        <a:t> the </a:t>
+                      </a:r>
+                      <a:r>
+                        <a:rPr lang="fr-FR" dirty="0" err="1" smtClean="0"/>
+                        <a:t>schematics</a:t>
+                      </a:r>
+                      <a:r>
+                        <a:rPr lang="fr-FR" dirty="0" smtClean="0"/>
+                        <a:t> and the RM on </a:t>
+                      </a:r>
+                      <a:r>
+                        <a:rPr lang="fr-FR" dirty="0" err="1" smtClean="0"/>
+                        <a:t>arduino</a:t>
+                      </a:r>
+                      <a:r>
+                        <a:rPr lang="fr-FR" baseline="0" dirty="0" smtClean="0"/>
+                        <a:t> </a:t>
+                      </a:r>
+                      <a:r>
+                        <a:rPr lang="fr-FR" baseline="0" dirty="0" err="1" smtClean="0"/>
+                        <a:t>connector</a:t>
+                      </a:r>
+                      <a:endParaRPr lang="fr-FR" baseline="0" dirty="0" smtClean="0"/>
+                    </a:p>
+                    <a:p>
+                      <a:r>
+                        <a:rPr lang="fr-FR" baseline="0" dirty="0" err="1" smtClean="0"/>
+                        <a:t>Find</a:t>
+                      </a:r>
+                      <a:r>
+                        <a:rPr lang="fr-FR" baseline="0" dirty="0" smtClean="0"/>
+                        <a:t> </a:t>
+                      </a:r>
+                      <a:r>
+                        <a:rPr lang="fr-FR" baseline="0" dirty="0" err="1" smtClean="0"/>
+                        <a:t>limit</a:t>
+                      </a:r>
+                      <a:r>
+                        <a:rPr lang="fr-FR" baseline="0" dirty="0" smtClean="0"/>
+                        <a:t> of the DK: </a:t>
+                      </a:r>
+                      <a:r>
+                        <a:rPr lang="fr-FR" baseline="0" dirty="0" err="1" smtClean="0"/>
+                        <a:t>too</a:t>
+                      </a:r>
+                      <a:r>
+                        <a:rPr lang="fr-FR" baseline="0" dirty="0" smtClean="0"/>
+                        <a:t> </a:t>
+                      </a:r>
+                      <a:r>
+                        <a:rPr lang="fr-FR" baseline="0" dirty="0" err="1" smtClean="0"/>
+                        <a:t>much</a:t>
+                      </a:r>
+                      <a:r>
+                        <a:rPr lang="fr-FR" baseline="0" dirty="0" smtClean="0"/>
+                        <a:t> </a:t>
+                      </a:r>
+                      <a:r>
+                        <a:rPr lang="fr-FR" baseline="0" dirty="0" err="1" smtClean="0"/>
+                        <a:t>stuff</a:t>
+                      </a:r>
+                      <a:r>
+                        <a:rPr lang="fr-FR" baseline="0" dirty="0" smtClean="0"/>
+                        <a:t> =&gt; </a:t>
+                      </a:r>
+                      <a:r>
+                        <a:rPr lang="fr-FR" baseline="0" dirty="0" err="1" smtClean="0"/>
+                        <a:t>find</a:t>
+                      </a:r>
+                      <a:r>
+                        <a:rPr lang="fr-FR" baseline="0" dirty="0" smtClean="0"/>
+                        <a:t> a signal in the middle of the </a:t>
+                      </a:r>
+                      <a:r>
+                        <a:rPr lang="fr-FR" baseline="0" dirty="0" err="1" smtClean="0"/>
+                        <a:t>board</a:t>
+                      </a:r>
+                      <a:r>
+                        <a:rPr lang="fr-FR" baseline="0" dirty="0" smtClean="0"/>
+                        <a:t> to </a:t>
+                      </a:r>
+                      <a:r>
+                        <a:rPr lang="fr-FR" baseline="0" dirty="0" err="1" smtClean="0"/>
+                        <a:t>extract</a:t>
+                      </a:r>
+                      <a:r>
+                        <a:rPr lang="fr-FR" baseline="0" dirty="0" smtClean="0"/>
+                        <a:t> a </a:t>
+                      </a:r>
+                      <a:r>
+                        <a:rPr lang="fr-FR" baseline="0" dirty="0" err="1" smtClean="0"/>
+                        <a:t>missing</a:t>
+                      </a:r>
+                      <a:r>
+                        <a:rPr lang="fr-FR" baseline="0" dirty="0" smtClean="0"/>
+                        <a:t> </a:t>
+                      </a:r>
+                      <a:r>
+                        <a:rPr lang="fr-FR" baseline="0" dirty="0" err="1" smtClean="0"/>
+                        <a:t>tim</a:t>
+                      </a:r>
+                      <a:r>
+                        <a:rPr lang="fr-FR" baseline="0" dirty="0" smtClean="0"/>
+                        <a:t> </a:t>
+                      </a:r>
+                      <a:r>
+                        <a:rPr lang="fr-FR" baseline="0" dirty="0" err="1" smtClean="0"/>
+                        <a:t>channel</a:t>
+                      </a:r>
+                      <a:r>
+                        <a:rPr lang="fr-FR" baseline="0" dirty="0" smtClean="0"/>
+                        <a:t> not </a:t>
+                      </a:r>
+                      <a:r>
+                        <a:rPr lang="fr-FR" baseline="0" dirty="0" err="1" smtClean="0"/>
+                        <a:t>available</a:t>
+                      </a:r>
+                      <a:r>
+                        <a:rPr lang="fr-FR" baseline="0" dirty="0" smtClean="0"/>
+                        <a:t> on </a:t>
+                      </a:r>
+                      <a:r>
+                        <a:rPr lang="fr-FR" baseline="0" dirty="0" err="1" smtClean="0"/>
+                        <a:t>Arduino</a:t>
+                      </a:r>
+                      <a:r>
+                        <a:rPr lang="fr-FR" baseline="0" dirty="0" smtClean="0"/>
+                        <a:t> </a:t>
+                      </a:r>
+                      <a:r>
+                        <a:rPr lang="fr-FR" baseline="0" dirty="0" err="1" smtClean="0"/>
+                        <a:t>conn</a:t>
+                      </a:r>
+                      <a:endParaRPr lang="fr-FR" baseline="0" dirty="0" smtClean="0"/>
+                    </a:p>
+                    <a:p>
+                      <a:r>
+                        <a:rPr lang="fr-FR" dirty="0" err="1" smtClean="0"/>
+                        <a:t>Proposed</a:t>
+                      </a:r>
+                      <a:r>
+                        <a:rPr lang="fr-FR" dirty="0" smtClean="0"/>
+                        <a:t> all allocations, </a:t>
+                      </a:r>
+                      <a:r>
+                        <a:rPr lang="fr-FR" dirty="0" err="1" smtClean="0"/>
+                        <a:t>mapped</a:t>
+                      </a:r>
+                      <a:r>
+                        <a:rPr lang="fr-FR" dirty="0" smtClean="0"/>
+                        <a:t> pins/</a:t>
+                      </a:r>
+                      <a:r>
+                        <a:rPr lang="fr-FR" dirty="0" err="1" smtClean="0"/>
+                        <a:t>Arduino</a:t>
+                      </a:r>
+                      <a:r>
+                        <a:rPr lang="fr-FR" dirty="0" smtClean="0"/>
+                        <a:t> </a:t>
+                      </a:r>
+                      <a:r>
+                        <a:rPr lang="fr-FR" dirty="0" err="1" smtClean="0"/>
+                        <a:t>connectors</a:t>
+                      </a:r>
+                      <a:r>
+                        <a:rPr lang="fr-FR" dirty="0" smtClean="0"/>
+                        <a:t> on </a:t>
+                      </a:r>
+                      <a:r>
+                        <a:rPr lang="fr-FR" dirty="0" err="1" smtClean="0"/>
+                        <a:t>each</a:t>
+                      </a:r>
+                      <a:r>
+                        <a:rPr lang="fr-FR" dirty="0" smtClean="0"/>
+                        <a:t> </a:t>
+                      </a:r>
+                      <a:r>
+                        <a:rPr lang="fr-FR" dirty="0" err="1" smtClean="0"/>
+                        <a:t>cards</a:t>
+                      </a:r>
+                      <a:endParaRPr lang="fr-FR" dirty="0"/>
+                    </a:p>
+                  </a:txBody>
+                  <a:tcPr/>
+                </a:tc>
+              </a:tr>
+              <a:tr h="370840">
+                <a:tc>
+                  <a:txBody>
+                    <a:bodyPr/>
+                    <a:lstStyle/>
+                    <a:p>
+                      <a:r>
+                        <a:rPr lang="fr-FR" dirty="0" smtClean="0"/>
+                        <a:t>Edition of the </a:t>
+                      </a:r>
+                      <a:r>
+                        <a:rPr lang="fr-FR" dirty="0" err="1" smtClean="0"/>
+                        <a:t>ioc</a:t>
+                      </a:r>
+                      <a:endParaRPr lang="fr-FR" dirty="0"/>
+                    </a:p>
+                  </a:txBody>
+                  <a:tcPr/>
+                </a:tc>
+                <a:tc>
+                  <a:txBody>
+                    <a:bodyPr/>
+                    <a:lstStyle/>
+                    <a:p>
+                      <a:r>
+                        <a:rPr lang="fr-FR" dirty="0" smtClean="0"/>
+                        <a:t>(5/5)</a:t>
+                      </a:r>
+                      <a:endParaRPr lang="fr-FR" dirty="0"/>
+                    </a:p>
+                  </a:txBody>
+                  <a:tcPr/>
+                </a:tc>
+                <a:tc>
+                  <a:txBody>
+                    <a:bodyPr/>
+                    <a:lstStyle/>
+                    <a:p>
+                      <a:r>
+                        <a:rPr lang="fr-FR" dirty="0" smtClean="0"/>
+                        <a:t>Not </a:t>
+                      </a:r>
+                      <a:r>
+                        <a:rPr lang="fr-FR" dirty="0" err="1" smtClean="0"/>
+                        <a:t>used</a:t>
+                      </a:r>
+                      <a:r>
+                        <a:rPr lang="fr-FR" dirty="0" smtClean="0"/>
+                        <a:t> a lot but </a:t>
+                      </a:r>
+                      <a:r>
+                        <a:rPr lang="fr-FR" dirty="0" err="1" smtClean="0"/>
+                        <a:t>visually</a:t>
+                      </a:r>
+                      <a:r>
+                        <a:rPr lang="fr-FR" dirty="0" smtClean="0"/>
+                        <a:t> </a:t>
+                      </a:r>
+                      <a:r>
+                        <a:rPr lang="fr-FR" dirty="0" err="1" smtClean="0"/>
+                        <a:t>it</a:t>
+                      </a:r>
+                      <a:r>
+                        <a:rPr lang="fr-FR" dirty="0" smtClean="0"/>
+                        <a:t> has </a:t>
+                      </a:r>
+                      <a:r>
+                        <a:rPr lang="fr-FR" dirty="0" err="1" smtClean="0"/>
+                        <a:t>done</a:t>
+                      </a:r>
+                      <a:r>
+                        <a:rPr lang="fr-FR" baseline="0" dirty="0" smtClean="0"/>
+                        <a:t> the job</a:t>
+                      </a:r>
+                      <a:endParaRPr lang="fr-FR" dirty="0"/>
+                    </a:p>
+                  </a:txBody>
+                  <a:tcPr/>
+                </a:tc>
+              </a:tr>
+              <a:tr h="370840">
+                <a:tc>
+                  <a:txBody>
+                    <a:bodyPr/>
+                    <a:lstStyle/>
+                    <a:p>
+                      <a:r>
+                        <a:rPr lang="fr-FR" dirty="0" err="1" smtClean="0"/>
+                        <a:t>Creation</a:t>
+                      </a:r>
+                      <a:r>
+                        <a:rPr lang="fr-FR" dirty="0" smtClean="0"/>
+                        <a:t> of the compilation </a:t>
+                      </a:r>
+                      <a:r>
+                        <a:rPr lang="fr-FR" dirty="0" err="1" smtClean="0"/>
+                        <a:t>chain</a:t>
+                      </a:r>
+                      <a:r>
+                        <a:rPr lang="fr-FR" baseline="0" dirty="0" smtClean="0"/>
+                        <a:t> (STM32CubeIDE files)</a:t>
+                      </a:r>
+                      <a:endParaRPr lang="fr-FR" dirty="0"/>
+                    </a:p>
+                  </a:txBody>
+                  <a:tcPr/>
+                </a:tc>
+                <a:tc>
+                  <a:txBody>
+                    <a:bodyPr/>
+                    <a:lstStyle/>
+                    <a:p>
+                      <a:r>
+                        <a:rPr lang="fr-FR" dirty="0" smtClean="0"/>
+                        <a:t>0/5</a:t>
+                      </a:r>
+                      <a:endParaRPr lang="fr-FR" dirty="0"/>
+                    </a:p>
+                  </a:txBody>
+                  <a:tcPr/>
+                </a:tc>
+                <a:tc>
+                  <a:txBody>
+                    <a:bodyPr/>
+                    <a:lstStyle/>
+                    <a:p>
+                      <a:r>
+                        <a:rPr lang="fr-FR" dirty="0" smtClean="0"/>
+                        <a:t>Not possible to </a:t>
+                      </a:r>
+                      <a:r>
+                        <a:rPr lang="fr-FR" dirty="0" err="1" smtClean="0"/>
+                        <a:t>create</a:t>
+                      </a:r>
+                      <a:r>
+                        <a:rPr lang="fr-FR" dirty="0" smtClean="0"/>
+                        <a:t> the .</a:t>
+                      </a:r>
+                      <a:r>
+                        <a:rPr lang="fr-FR" dirty="0" err="1" smtClean="0"/>
+                        <a:t>cproject</a:t>
+                      </a:r>
+                      <a:r>
+                        <a:rPr lang="fr-FR" dirty="0" smtClean="0"/>
+                        <a:t> and .</a:t>
+                      </a:r>
+                      <a:r>
+                        <a:rPr lang="fr-FR" dirty="0" err="1" smtClean="0"/>
+                        <a:t>project</a:t>
+                      </a:r>
+                      <a:r>
+                        <a:rPr lang="fr-FR" dirty="0" smtClean="0"/>
+                        <a:t>.</a:t>
+                      </a:r>
+                    </a:p>
+                    <a:p>
+                      <a:r>
+                        <a:rPr lang="fr-FR" dirty="0" err="1" smtClean="0"/>
+                        <a:t>Create</a:t>
+                      </a:r>
+                      <a:r>
+                        <a:rPr lang="fr-FR" dirty="0" smtClean="0"/>
+                        <a:t> an </a:t>
+                      </a:r>
+                      <a:r>
+                        <a:rPr lang="fr-FR" dirty="0" err="1" smtClean="0"/>
+                        <a:t>empty</a:t>
+                      </a:r>
+                      <a:r>
+                        <a:rPr lang="fr-FR" dirty="0" smtClean="0"/>
+                        <a:t> one and </a:t>
+                      </a:r>
+                      <a:r>
+                        <a:rPr lang="fr-FR" dirty="0" err="1" smtClean="0"/>
+                        <a:t>then</a:t>
+                      </a:r>
+                      <a:r>
+                        <a:rPr lang="fr-FR" dirty="0" smtClean="0"/>
+                        <a:t> able to ADD/REMOVE files</a:t>
+                      </a:r>
+                      <a:r>
+                        <a:rPr lang="fr-FR" baseline="0" dirty="0" smtClean="0"/>
+                        <a:t> or options</a:t>
+                      </a:r>
+                      <a:endParaRPr lang="fr-FR" dirty="0"/>
+                    </a:p>
+                  </a:txBody>
+                  <a:tcPr/>
+                </a:tc>
+              </a:tr>
+              <a:tr h="370840">
+                <a:tc>
+                  <a:txBody>
+                    <a:bodyPr/>
+                    <a:lstStyle/>
+                    <a:p>
+                      <a:r>
+                        <a:rPr lang="fr-FR" dirty="0" err="1" smtClean="0"/>
+                        <a:t>Generation</a:t>
+                      </a:r>
+                      <a:r>
+                        <a:rPr lang="fr-FR" dirty="0" smtClean="0"/>
+                        <a:t> of C</a:t>
+                      </a:r>
+                      <a:endParaRPr lang="fr-FR" dirty="0"/>
+                    </a:p>
+                  </a:txBody>
+                  <a:tcPr/>
+                </a:tc>
+                <a:tc>
+                  <a:txBody>
+                    <a:bodyPr/>
+                    <a:lstStyle/>
+                    <a:p>
+                      <a:r>
+                        <a:rPr lang="fr-FR" dirty="0" smtClean="0"/>
+                        <a:t>5/5</a:t>
+                      </a:r>
+                      <a:endParaRPr lang="fr-FR" dirty="0"/>
+                    </a:p>
+                  </a:txBody>
+                  <a:tcPr/>
+                </a:tc>
+                <a:tc>
+                  <a:txBody>
+                    <a:bodyPr/>
+                    <a:lstStyle/>
+                    <a:p>
+                      <a:r>
+                        <a:rPr lang="fr-FR" dirty="0" smtClean="0"/>
+                        <a:t>No issue to </a:t>
+                      </a:r>
+                      <a:r>
+                        <a:rPr lang="fr-FR" dirty="0" err="1" smtClean="0"/>
+                        <a:t>generate</a:t>
+                      </a:r>
+                      <a:r>
+                        <a:rPr lang="fr-FR" dirty="0" smtClean="0"/>
+                        <a:t> all aspects of the </a:t>
+                      </a:r>
+                      <a:r>
+                        <a:rPr lang="fr-FR" dirty="0" err="1" smtClean="0"/>
+                        <a:t>project</a:t>
+                      </a:r>
+                      <a:r>
+                        <a:rPr lang="fr-FR" dirty="0" smtClean="0"/>
+                        <a:t>.</a:t>
+                      </a:r>
+                      <a:r>
+                        <a:rPr lang="fr-FR" baseline="0" dirty="0" smtClean="0"/>
+                        <a:t> </a:t>
+                      </a:r>
+                      <a:r>
+                        <a:rPr lang="fr-FR" baseline="0" dirty="0" err="1" smtClean="0"/>
+                        <a:t>FreeRTOS</a:t>
+                      </a:r>
+                      <a:r>
+                        <a:rPr lang="fr-FR" baseline="0" dirty="0" smtClean="0"/>
+                        <a:t> + </a:t>
+                      </a:r>
+                      <a:r>
+                        <a:rPr lang="fr-FR" baseline="0" dirty="0" err="1" smtClean="0"/>
+                        <a:t>algo</a:t>
+                      </a:r>
+                      <a:endParaRPr lang="fr-FR" dirty="0"/>
+                    </a:p>
+                  </a:txBody>
+                  <a:tcPr/>
+                </a:tc>
+              </a:tr>
+              <a:tr h="370840">
+                <a:tc>
+                  <a:txBody>
+                    <a:bodyPr/>
+                    <a:lstStyle/>
+                    <a:p>
+                      <a:endParaRPr lang="fr-FR" dirty="0"/>
+                    </a:p>
+                  </a:txBody>
+                  <a:tcPr/>
+                </a:tc>
+                <a:tc>
+                  <a:txBody>
+                    <a:bodyPr/>
+                    <a:lstStyle/>
+                    <a:p>
+                      <a:endParaRPr lang="fr-FR" dirty="0"/>
+                    </a:p>
+                  </a:txBody>
+                  <a:tcPr/>
+                </a:tc>
+                <a:tc>
+                  <a:txBody>
+                    <a:bodyPr/>
+                    <a:lstStyle/>
+                    <a:p>
+                      <a:endParaRPr lang="fr-FR" dirty="0"/>
+                    </a:p>
+                  </a:txBody>
+                  <a:tcPr/>
+                </a:tc>
+              </a:tr>
+            </a:tbl>
+          </a:graphicData>
+        </a:graphic>
+      </p:graphicFrame>
+    </p:spTree>
+  </p:cSld>
+  <p:clrMapOvr>
+    <a:masterClrMapping/>
+  </p:clrMapOvr>
+</p:sld>
+</file>
+
+<file path=ppt/slides/slide2.xml><?xml version="1.0" encoding="utf-8"?>
+<p:sld xmlns:a="http://schemas.openxmlformats.org/drawingml/2006/main" xmlns:r="http://schemas.openxmlformats.org/officeDocument/2006/relationships" xmlns:p="http://schemas.openxmlformats.org/presentationml/2006/main">
+  <p:cSld>
+    <p:spTree>
+      <p:nvGrpSpPr>
+        <p:cNvPr id="1" name=""/>
+        <p:cNvGrpSpPr/>
+        <p:nvPr/>
+      </p:nvGrpSpPr>
+      <p:grpSpPr>
+        <a:xfrm>
+          <a:off x="0" y="0"/>
+          <a:ext cx="0" cy="0"/>
+          <a:chOff x="0" y="0"/>
+          <a:chExt cx="0" cy="0"/>
+        </a:xfrm>
+      </p:grpSpPr>
+      <p:sp>
+        <p:nvSpPr>
+          <p:cNvPr id="2" name="Titre 1"/>
+          <p:cNvSpPr>
+            <a:spLocks noGrp="1"/>
+          </p:cNvSpPr>
+          <p:nvPr>
+            <p:ph type="title"/>
+          </p:nvPr>
+        </p:nvSpPr>
+        <p:spPr>
+          <a:xfrm>
+            <a:off x="457200" y="39762"/>
+            <a:ext cx="8229600" cy="436910"/>
+          </a:xfrm>
+        </p:spPr>
+        <p:txBody>
+          <a:bodyPr>
+            <a:normAutofit fontScale="90000"/>
+          </a:bodyPr>
+          <a:lstStyle/>
+          <a:p>
+            <a:r>
+              <a:rPr lang="fr-FR" dirty="0" smtClean="0"/>
+              <a:t>Robot inverse </a:t>
+            </a:r>
+            <a:r>
+              <a:rPr lang="fr-FR" dirty="0" err="1" smtClean="0"/>
+              <a:t>pendulum</a:t>
+            </a:r>
+            <a:endParaRPr lang="fr-FR" dirty="0"/>
+          </a:p>
+        </p:txBody>
+      </p:sp>
+      <p:graphicFrame>
+        <p:nvGraphicFramePr>
+          <p:cNvPr id="4" name="Espace réservé du contenu 3"/>
+          <p:cNvGraphicFramePr>
+            <a:graphicFrameLocks noGrp="1"/>
+          </p:cNvGraphicFramePr>
+          <p:nvPr>
+            <p:ph idx="1"/>
+          </p:nvPr>
+        </p:nvGraphicFramePr>
+        <p:xfrm>
+          <a:off x="107503" y="548680"/>
+          <a:ext cx="9036497" cy="5781040"/>
+        </p:xfrm>
+        <a:graphic>
+          <a:graphicData uri="http://schemas.openxmlformats.org/drawingml/2006/table">
+            <a:tbl>
+              <a:tblPr firstRow="1" bandRow="1">
+                <a:tableStyleId>{5C22544A-7EE6-4342-B048-85BDC9FD1C3A}</a:tableStyleId>
+              </a:tblPr>
+              <a:tblGrid>
+                <a:gridCol w="3223457"/>
+                <a:gridCol w="688387"/>
+                <a:gridCol w="5124653"/>
+              </a:tblGrid>
+              <a:tr h="370840">
+                <a:tc>
+                  <a:txBody>
+                    <a:bodyPr/>
+                    <a:lstStyle/>
+                    <a:p>
+                      <a:endParaRPr lang="fr-FR" dirty="0"/>
+                    </a:p>
+                  </a:txBody>
+                  <a:tcPr/>
+                </a:tc>
+                <a:tc>
+                  <a:txBody>
+                    <a:bodyPr/>
+                    <a:lstStyle/>
+                    <a:p>
+                      <a:endParaRPr lang="fr-FR" dirty="0"/>
+                    </a:p>
+                  </a:txBody>
+                  <a:tcPr/>
+                </a:tc>
+                <a:tc>
+                  <a:txBody>
+                    <a:bodyPr/>
+                    <a:lstStyle/>
+                    <a:p>
+                      <a:endParaRPr lang="fr-FR" dirty="0"/>
+                    </a:p>
+                  </a:txBody>
+                  <a:tcPr/>
+                </a:tc>
+              </a:tr>
+              <a:tr h="370840">
+                <a:tc>
+                  <a:txBody>
+                    <a:bodyPr/>
+                    <a:lstStyle/>
+                    <a:p>
+                      <a:r>
+                        <a:rPr lang="fr-FR" dirty="0" err="1" smtClean="0"/>
+                        <a:t>Generation</a:t>
+                      </a:r>
+                      <a:r>
+                        <a:rPr lang="fr-FR" dirty="0" smtClean="0"/>
+                        <a:t> of python</a:t>
+                      </a:r>
+                      <a:endParaRPr lang="fr-FR" dirty="0"/>
+                    </a:p>
+                  </a:txBody>
+                  <a:tcPr/>
+                </a:tc>
+                <a:tc>
+                  <a:txBody>
+                    <a:bodyPr/>
+                    <a:lstStyle/>
+                    <a:p>
+                      <a:r>
+                        <a:rPr lang="fr-FR" dirty="0" smtClean="0"/>
+                        <a:t>5/5</a:t>
+                      </a:r>
+                      <a:endParaRPr lang="fr-FR" dirty="0"/>
+                    </a:p>
+                  </a:txBody>
+                  <a:tcPr/>
+                </a:tc>
+                <a:tc>
+                  <a:txBody>
+                    <a:bodyPr/>
+                    <a:lstStyle/>
+                    <a:p>
+                      <a:r>
+                        <a:rPr lang="fr-FR" dirty="0" smtClean="0"/>
+                        <a:t>Propose and </a:t>
+                      </a:r>
+                      <a:r>
+                        <a:rPr lang="fr-FR" dirty="0" err="1" smtClean="0"/>
+                        <a:t>implement</a:t>
+                      </a:r>
+                      <a:r>
+                        <a:rPr lang="fr-FR" dirty="0" smtClean="0"/>
+                        <a:t> </a:t>
+                      </a:r>
+                      <a:r>
+                        <a:rPr lang="fr-FR" dirty="0" err="1" smtClean="0"/>
+                        <a:t>very</a:t>
+                      </a:r>
+                      <a:r>
+                        <a:rPr lang="fr-FR" dirty="0" smtClean="0"/>
+                        <a:t> </a:t>
+                      </a:r>
+                      <a:r>
+                        <a:rPr lang="fr-FR" dirty="0" err="1" smtClean="0"/>
+                        <a:t>high</a:t>
+                      </a:r>
+                      <a:r>
+                        <a:rPr lang="fr-FR" dirty="0" smtClean="0"/>
+                        <a:t> </a:t>
+                      </a:r>
+                      <a:r>
+                        <a:rPr lang="fr-FR" dirty="0" err="1" smtClean="0"/>
+                        <a:t>quality</a:t>
+                      </a:r>
+                      <a:r>
+                        <a:rPr lang="fr-FR" dirty="0" smtClean="0"/>
+                        <a:t> interfaces</a:t>
+                      </a:r>
+                      <a:endParaRPr lang="fr-FR" dirty="0"/>
+                    </a:p>
+                  </a:txBody>
+                  <a:tcPr/>
+                </a:tc>
+              </a:tr>
+              <a:tr h="370840">
+                <a:tc>
+                  <a:txBody>
+                    <a:bodyPr/>
+                    <a:lstStyle/>
+                    <a:p>
+                      <a:r>
+                        <a:rPr lang="fr-FR" dirty="0" err="1" smtClean="0"/>
+                        <a:t>Generation</a:t>
+                      </a:r>
+                      <a:r>
+                        <a:rPr lang="fr-FR" dirty="0" smtClean="0"/>
+                        <a:t> of </a:t>
+                      </a:r>
+                      <a:r>
+                        <a:rPr lang="fr-FR" dirty="0" err="1" smtClean="0"/>
+                        <a:t>unitary</a:t>
+                      </a:r>
+                      <a:r>
+                        <a:rPr lang="fr-FR" dirty="0" smtClean="0"/>
+                        <a:t> test</a:t>
+                      </a:r>
+                      <a:endParaRPr lang="fr-FR" dirty="0"/>
+                    </a:p>
+                  </a:txBody>
+                  <a:tcPr/>
+                </a:tc>
+                <a:tc>
+                  <a:txBody>
+                    <a:bodyPr/>
+                    <a:lstStyle/>
+                    <a:p>
+                      <a:r>
+                        <a:rPr lang="fr-FR" dirty="0" smtClean="0"/>
+                        <a:t>4.9/5</a:t>
+                      </a:r>
+                      <a:endParaRPr lang="fr-FR" dirty="0"/>
+                    </a:p>
+                  </a:txBody>
+                  <a:tcPr/>
+                </a:tc>
+                <a:tc>
+                  <a:txBody>
+                    <a:bodyPr/>
+                    <a:lstStyle/>
+                    <a:p>
+                      <a:r>
+                        <a:rPr lang="fr-FR" dirty="0" smtClean="0"/>
+                        <a:t>Propose </a:t>
+                      </a:r>
+                      <a:r>
+                        <a:rPr lang="fr-FR" dirty="0" err="1" smtClean="0"/>
+                        <a:t>dedicated</a:t>
+                      </a:r>
+                      <a:r>
+                        <a:rPr lang="fr-FR" dirty="0" smtClean="0"/>
+                        <a:t> interface in the </a:t>
+                      </a:r>
+                      <a:r>
+                        <a:rPr lang="fr-FR" dirty="0" err="1" smtClean="0"/>
+                        <a:t>small</a:t>
+                      </a:r>
+                      <a:r>
+                        <a:rPr lang="fr-FR" dirty="0" smtClean="0"/>
+                        <a:t> DK </a:t>
+                      </a:r>
+                      <a:r>
+                        <a:rPr lang="fr-FR" dirty="0" err="1" smtClean="0"/>
+                        <a:t>screen</a:t>
+                      </a:r>
+                      <a:r>
+                        <a:rPr lang="fr-FR" dirty="0" smtClean="0"/>
+                        <a:t> for </a:t>
+                      </a:r>
+                      <a:r>
+                        <a:rPr lang="fr-FR" dirty="0" err="1" smtClean="0"/>
+                        <a:t>each</a:t>
+                      </a:r>
+                      <a:r>
+                        <a:rPr lang="fr-FR" dirty="0" smtClean="0"/>
+                        <a:t> aspect of the robot  (</a:t>
+                      </a:r>
+                      <a:r>
+                        <a:rPr lang="fr-FR" dirty="0" err="1" smtClean="0"/>
+                        <a:t>motor</a:t>
+                      </a:r>
+                      <a:r>
+                        <a:rPr lang="fr-FR" dirty="0" smtClean="0"/>
+                        <a:t>, encoder, TOF) + </a:t>
+                      </a:r>
+                      <a:r>
+                        <a:rPr lang="fr-FR" dirty="0" err="1" smtClean="0"/>
+                        <a:t>dedicated</a:t>
+                      </a:r>
+                      <a:r>
+                        <a:rPr lang="fr-FR" dirty="0" smtClean="0"/>
+                        <a:t> python</a:t>
+                      </a:r>
+                      <a:r>
+                        <a:rPr lang="fr-FR" baseline="0" dirty="0" smtClean="0"/>
+                        <a:t> </a:t>
+                      </a:r>
+                      <a:r>
+                        <a:rPr lang="fr-FR" baseline="0" dirty="0" err="1" smtClean="0"/>
+                        <a:t>telemetry</a:t>
+                      </a:r>
+                      <a:r>
+                        <a:rPr lang="fr-FR" baseline="0" dirty="0" smtClean="0"/>
+                        <a:t> and </a:t>
+                      </a:r>
+                      <a:r>
+                        <a:rPr lang="fr-FR" baseline="0" dirty="0" err="1" smtClean="0"/>
+                        <a:t>access</a:t>
+                      </a:r>
+                      <a:r>
+                        <a:rPr lang="fr-FR" baseline="0" dirty="0" smtClean="0"/>
+                        <a:t> if </a:t>
+                      </a:r>
+                      <a:r>
+                        <a:rPr lang="fr-FR" baseline="0" dirty="0" err="1" smtClean="0"/>
+                        <a:t>required</a:t>
+                      </a:r>
+                      <a:r>
+                        <a:rPr lang="fr-FR" baseline="0" dirty="0" smtClean="0"/>
+                        <a:t> </a:t>
+                      </a:r>
+                      <a:r>
+                        <a:rPr lang="fr-FR" baseline="0" dirty="0" err="1" smtClean="0"/>
+                        <a:t>with</a:t>
+                      </a:r>
+                      <a:r>
+                        <a:rPr lang="fr-FR" baseline="0" dirty="0" smtClean="0"/>
+                        <a:t> python GUI.</a:t>
+                      </a:r>
+                      <a:endParaRPr lang="fr-FR" dirty="0"/>
+                    </a:p>
+                  </a:txBody>
+                  <a:tcPr/>
+                </a:tc>
+              </a:tr>
+              <a:tr h="370840">
+                <a:tc>
+                  <a:txBody>
+                    <a:bodyPr/>
+                    <a:lstStyle/>
+                    <a:p>
+                      <a:r>
+                        <a:rPr lang="fr-FR" dirty="0" err="1" smtClean="0"/>
+                        <a:t>Generation</a:t>
+                      </a:r>
+                      <a:r>
+                        <a:rPr lang="fr-FR" dirty="0" smtClean="0"/>
+                        <a:t> of the </a:t>
+                      </a:r>
+                      <a:r>
+                        <a:rPr lang="fr-FR" dirty="0" err="1" smtClean="0"/>
+                        <a:t>complete</a:t>
+                      </a:r>
+                      <a:r>
+                        <a:rPr lang="fr-FR" baseline="0" dirty="0" smtClean="0"/>
+                        <a:t> application</a:t>
+                      </a:r>
+                      <a:endParaRPr lang="fr-FR" dirty="0"/>
+                    </a:p>
+                  </a:txBody>
+                  <a:tcPr/>
+                </a:tc>
+                <a:tc>
+                  <a:txBody>
+                    <a:bodyPr/>
+                    <a:lstStyle/>
+                    <a:p>
+                      <a:r>
+                        <a:rPr lang="fr-FR" dirty="0" smtClean="0"/>
+                        <a:t>4,9/5</a:t>
+                      </a:r>
+                      <a:endParaRPr lang="fr-FR" dirty="0"/>
+                    </a:p>
+                  </a:txBody>
+                  <a:tcPr/>
+                </a:tc>
+                <a:tc>
+                  <a:txBody>
+                    <a:bodyPr/>
+                    <a:lstStyle/>
+                    <a:p>
+                      <a:r>
+                        <a:rPr lang="fr-FR" dirty="0" smtClean="0"/>
+                        <a:t>All aspect of the C code </a:t>
+                      </a:r>
+                      <a:r>
+                        <a:rPr lang="fr-FR" dirty="0" err="1" smtClean="0"/>
+                        <a:t>is</a:t>
+                      </a:r>
+                      <a:r>
+                        <a:rPr lang="fr-FR" dirty="0" smtClean="0"/>
+                        <a:t> </a:t>
+                      </a:r>
+                      <a:r>
+                        <a:rPr lang="fr-FR" dirty="0" err="1" smtClean="0"/>
+                        <a:t>masterised</a:t>
+                      </a:r>
+                      <a:r>
+                        <a:rPr lang="fr-FR" dirty="0" smtClean="0"/>
+                        <a:t>.</a:t>
+                      </a:r>
+                      <a:endParaRPr lang="fr-FR" dirty="0"/>
+                    </a:p>
+                  </a:txBody>
+                  <a:tcPr/>
+                </a:tc>
+              </a:tr>
+              <a:tr h="370840">
+                <a:tc>
+                  <a:txBody>
+                    <a:bodyPr/>
+                    <a:lstStyle/>
+                    <a:p>
+                      <a:r>
+                        <a:rPr lang="fr-FR" dirty="0" err="1" smtClean="0"/>
+                        <a:t>Debugging</a:t>
+                      </a:r>
+                      <a:endParaRPr lang="fr-FR" dirty="0"/>
+                    </a:p>
+                  </a:txBody>
+                  <a:tcPr/>
+                </a:tc>
+                <a:tc>
+                  <a:txBody>
+                    <a:bodyPr/>
+                    <a:lstStyle/>
+                    <a:p>
+                      <a:r>
+                        <a:rPr lang="fr-FR" dirty="0" smtClean="0"/>
+                        <a:t>IDK</a:t>
+                      </a:r>
+                      <a:endParaRPr lang="fr-FR" dirty="0"/>
+                    </a:p>
+                  </a:txBody>
+                  <a:tcPr/>
+                </a:tc>
+                <a:tc>
+                  <a:txBody>
+                    <a:bodyPr/>
+                    <a:lstStyle/>
+                    <a:p>
+                      <a:r>
+                        <a:rPr lang="fr-FR" dirty="0" smtClean="0"/>
+                        <a:t>Not </a:t>
+                      </a:r>
+                      <a:r>
+                        <a:rPr lang="fr-FR" dirty="0" err="1" smtClean="0"/>
+                        <a:t>done</a:t>
+                      </a:r>
+                      <a:r>
+                        <a:rPr lang="fr-FR" dirty="0" smtClean="0"/>
+                        <a:t> </a:t>
+                      </a:r>
+                      <a:r>
+                        <a:rPr lang="fr-FR" dirty="0" err="1" smtClean="0"/>
+                        <a:t>it</a:t>
+                      </a:r>
+                      <a:r>
+                        <a:rPr lang="fr-FR" dirty="0" smtClean="0"/>
+                        <a:t> </a:t>
+                      </a:r>
+                      <a:r>
+                        <a:rPr lang="fr-FR" dirty="0" err="1" smtClean="0"/>
+                        <a:t>with</a:t>
+                      </a:r>
+                      <a:r>
+                        <a:rPr lang="fr-FR" dirty="0" smtClean="0"/>
+                        <a:t> IA as not </a:t>
+                      </a:r>
+                      <a:r>
+                        <a:rPr lang="fr-FR" dirty="0" err="1" smtClean="0"/>
+                        <a:t>done</a:t>
+                      </a:r>
+                      <a:r>
+                        <a:rPr lang="fr-FR" dirty="0" smtClean="0"/>
+                        <a:t> </a:t>
+                      </a:r>
+                      <a:r>
+                        <a:rPr lang="fr-FR" dirty="0" err="1" smtClean="0"/>
+                        <a:t>it</a:t>
+                      </a:r>
+                      <a:r>
+                        <a:rPr lang="fr-FR" dirty="0" smtClean="0"/>
+                        <a:t> </a:t>
+                      </a:r>
+                      <a:r>
+                        <a:rPr lang="fr-FR" dirty="0" err="1" smtClean="0"/>
+                        <a:t>almost</a:t>
+                      </a:r>
+                      <a:r>
+                        <a:rPr lang="fr-FR" dirty="0" smtClean="0"/>
+                        <a:t>.</a:t>
+                      </a:r>
+                      <a:endParaRPr lang="fr-FR" dirty="0"/>
+                    </a:p>
+                  </a:txBody>
+                  <a:tcPr/>
+                </a:tc>
+              </a:tr>
+              <a:tr h="370840">
+                <a:tc>
+                  <a:txBody>
+                    <a:bodyPr/>
+                    <a:lstStyle/>
+                    <a:p>
+                      <a:r>
+                        <a:rPr lang="fr-FR" dirty="0" smtClean="0"/>
+                        <a:t>Tips</a:t>
+                      </a:r>
+                      <a:endParaRPr lang="fr-FR" dirty="0"/>
+                    </a:p>
+                  </a:txBody>
+                  <a:tcPr/>
+                </a:tc>
+                <a:tc>
+                  <a:txBody>
+                    <a:bodyPr/>
+                    <a:lstStyle/>
+                    <a:p>
+                      <a:r>
+                        <a:rPr lang="fr-FR" dirty="0" smtClean="0"/>
+                        <a:t>4,9/5</a:t>
+                      </a:r>
+                      <a:endParaRPr lang="fr-FR" dirty="0"/>
+                    </a:p>
+                  </a:txBody>
+                  <a:tcPr/>
+                </a:tc>
+                <a:tc>
+                  <a:txBody>
+                    <a:bodyPr/>
+                    <a:lstStyle/>
+                    <a:p>
+                      <a:r>
+                        <a:rPr lang="fr-FR" dirty="0" smtClean="0"/>
+                        <a:t>In all </a:t>
+                      </a:r>
+                      <a:r>
+                        <a:rPr lang="fr-FR" dirty="0" err="1" smtClean="0"/>
+                        <a:t>apsects</a:t>
+                      </a:r>
+                      <a:r>
+                        <a:rPr lang="fr-FR" dirty="0" smtClean="0"/>
+                        <a:t>, </a:t>
+                      </a:r>
+                      <a:r>
+                        <a:rPr lang="fr-FR" dirty="0" err="1" smtClean="0"/>
+                        <a:t>theory</a:t>
+                      </a:r>
+                      <a:r>
+                        <a:rPr lang="fr-FR" dirty="0" smtClean="0"/>
+                        <a:t> of </a:t>
+                      </a:r>
+                      <a:r>
+                        <a:rPr lang="fr-FR" dirty="0" err="1" smtClean="0"/>
+                        <a:t>pendulum</a:t>
+                      </a:r>
+                      <a:r>
+                        <a:rPr lang="fr-FR" dirty="0" smtClean="0"/>
+                        <a:t>, </a:t>
+                      </a:r>
+                      <a:r>
+                        <a:rPr lang="fr-FR" dirty="0" err="1" smtClean="0"/>
+                        <a:t>telemetry</a:t>
+                      </a:r>
+                      <a:r>
+                        <a:rPr lang="fr-FR" dirty="0" smtClean="0"/>
+                        <a:t>, power, </a:t>
+                      </a:r>
+                      <a:r>
+                        <a:rPr lang="fr-FR" dirty="0" err="1" smtClean="0"/>
+                        <a:t>practical</a:t>
+                      </a:r>
+                      <a:r>
+                        <a:rPr lang="fr-FR" dirty="0" smtClean="0"/>
+                        <a:t> </a:t>
+                      </a:r>
+                      <a:r>
+                        <a:rPr lang="fr-FR" dirty="0" err="1" smtClean="0"/>
+                        <a:t>it</a:t>
+                      </a:r>
+                      <a:r>
+                        <a:rPr lang="fr-FR" dirty="0" smtClean="0"/>
+                        <a:t> </a:t>
+                      </a:r>
+                      <a:r>
+                        <a:rPr lang="fr-FR" dirty="0" err="1" smtClean="0"/>
+                        <a:t>is</a:t>
+                      </a:r>
+                      <a:r>
+                        <a:rPr lang="fr-FR" dirty="0" smtClean="0"/>
+                        <a:t> exact.</a:t>
+                      </a:r>
+                      <a:endParaRPr lang="fr-FR" dirty="0"/>
+                    </a:p>
+                  </a:txBody>
+                  <a:tcPr/>
+                </a:tc>
+              </a:tr>
+              <a:tr h="370840">
+                <a:tc gridSpan="3">
+                  <a:txBody>
+                    <a:bodyPr/>
+                    <a:lstStyle/>
+                    <a:p>
+                      <a:r>
+                        <a:rPr lang="fr-FR" dirty="0" smtClean="0"/>
+                        <a:t>But</a:t>
+                      </a:r>
+                      <a:endParaRPr lang="fr-FR" dirty="0"/>
+                    </a:p>
+                  </a:txBody>
+                  <a:tcPr/>
+                </a:tc>
+                <a:tc hMerge="1">
+                  <a:txBody>
+                    <a:bodyPr/>
+                    <a:lstStyle/>
+                    <a:p>
+                      <a:endParaRPr lang="fr-FR" dirty="0"/>
+                    </a:p>
+                  </a:txBody>
+                  <a:tcPr/>
+                </a:tc>
+                <a:tc hMerge="1">
+                  <a:txBody>
+                    <a:bodyPr/>
+                    <a:lstStyle/>
+                    <a:p>
+                      <a:endParaRPr lang="fr-FR" dirty="0"/>
+                    </a:p>
+                  </a:txBody>
+                  <a:tcPr/>
+                </a:tc>
+              </a:tr>
+              <a:tr h="370840">
+                <a:tc rowSpan="2">
+                  <a:txBody>
+                    <a:bodyPr/>
+                    <a:lstStyle/>
+                    <a:p>
+                      <a:r>
+                        <a:rPr lang="fr-FR" dirty="0" err="1" smtClean="0"/>
+                        <a:t>Spend</a:t>
+                      </a:r>
+                      <a:r>
+                        <a:rPr lang="fr-FR" dirty="0" smtClean="0"/>
+                        <a:t> 2 </a:t>
+                      </a:r>
+                      <a:r>
+                        <a:rPr lang="fr-FR" dirty="0" err="1" smtClean="0"/>
+                        <a:t>weeks</a:t>
+                      </a:r>
+                      <a:r>
+                        <a:rPr lang="fr-FR" baseline="0" dirty="0" smtClean="0"/>
+                        <a:t> </a:t>
+                      </a:r>
+                      <a:r>
+                        <a:rPr lang="fr-FR" baseline="0" dirty="0" err="1" smtClean="0"/>
+                        <a:t>trying</a:t>
+                      </a:r>
+                      <a:r>
+                        <a:rPr lang="fr-FR" baseline="0" dirty="0" smtClean="0"/>
+                        <a:t> to </a:t>
+                      </a:r>
+                      <a:r>
+                        <a:rPr lang="fr-FR" baseline="0" dirty="0" err="1" smtClean="0"/>
+                        <a:t>make</a:t>
+                      </a:r>
+                      <a:r>
+                        <a:rPr lang="fr-FR" baseline="0" dirty="0" smtClean="0"/>
+                        <a:t> </a:t>
+                      </a:r>
+                      <a:r>
+                        <a:rPr lang="fr-FR" baseline="0" dirty="0" err="1" smtClean="0"/>
+                        <a:t>it</a:t>
+                      </a:r>
+                      <a:r>
+                        <a:rPr lang="fr-FR" baseline="0" dirty="0" smtClean="0"/>
+                        <a:t> stand on </a:t>
+                      </a:r>
+                      <a:r>
+                        <a:rPr lang="fr-FR" baseline="0" dirty="0" err="1" smtClean="0"/>
+                        <a:t>his</a:t>
+                      </a:r>
+                      <a:r>
+                        <a:rPr lang="fr-FR" baseline="0" dirty="0" smtClean="0"/>
+                        <a:t> 2 </a:t>
+                      </a:r>
+                      <a:r>
+                        <a:rPr lang="fr-FR" baseline="0" dirty="0" err="1" smtClean="0"/>
+                        <a:t>wheel</a:t>
+                      </a:r>
+                      <a:endParaRPr lang="fr-FR" dirty="0"/>
+                    </a:p>
+                  </a:txBody>
+                  <a:tcPr/>
+                </a:tc>
+                <a:tc>
+                  <a:txBody>
+                    <a:bodyPr/>
+                    <a:lstStyle/>
+                    <a:p>
+                      <a:endParaRPr lang="fr-FR" dirty="0"/>
+                    </a:p>
+                  </a:txBody>
+                  <a:tcPr/>
+                </a:tc>
+                <a:tc>
+                  <a:txBody>
+                    <a:bodyPr/>
+                    <a:lstStyle/>
+                    <a:p>
+                      <a:r>
+                        <a:rPr lang="fr-FR" dirty="0" err="1" smtClean="0"/>
+                        <a:t>Tested</a:t>
+                      </a:r>
+                      <a:r>
+                        <a:rPr lang="fr-FR" dirty="0" smtClean="0"/>
+                        <a:t> </a:t>
+                      </a:r>
+                      <a:r>
+                        <a:rPr lang="fr-FR" dirty="0" err="1" smtClean="0"/>
+                        <a:t>manually</a:t>
+                      </a:r>
+                      <a:r>
+                        <a:rPr lang="fr-FR" dirty="0" smtClean="0"/>
+                        <a:t> to set the PID</a:t>
+                      </a:r>
+                    </a:p>
+                    <a:p>
+                      <a:r>
+                        <a:rPr lang="fr-FR" dirty="0" err="1" smtClean="0"/>
+                        <a:t>Tested</a:t>
+                      </a:r>
+                      <a:r>
+                        <a:rPr lang="fr-FR" dirty="0" smtClean="0"/>
+                        <a:t> </a:t>
+                      </a:r>
+                      <a:r>
+                        <a:rPr lang="fr-FR" dirty="0" err="1" smtClean="0"/>
+                        <a:t>programmatically</a:t>
+                      </a:r>
+                      <a:r>
+                        <a:rPr lang="fr-FR" dirty="0" smtClean="0"/>
+                        <a:t> to set the </a:t>
+                      </a:r>
+                      <a:r>
+                        <a:rPr lang="fr-FR" dirty="0" err="1" smtClean="0"/>
+                        <a:t>pid</a:t>
+                      </a:r>
+                      <a:endParaRPr lang="fr-FR" dirty="0" smtClean="0"/>
+                    </a:p>
+                    <a:p>
+                      <a:r>
+                        <a:rPr lang="fr-FR" dirty="0" err="1" smtClean="0"/>
+                        <a:t>Tested</a:t>
+                      </a:r>
+                      <a:r>
+                        <a:rPr lang="fr-FR" dirty="0" smtClean="0"/>
+                        <a:t> </a:t>
+                      </a:r>
+                      <a:r>
+                        <a:rPr lang="fr-FR" dirty="0" err="1" smtClean="0"/>
+                        <a:t>with</a:t>
+                      </a:r>
+                      <a:r>
+                        <a:rPr lang="fr-FR" dirty="0" smtClean="0"/>
+                        <a:t> MCP to set the PID</a:t>
+                      </a:r>
+                    </a:p>
+                    <a:p>
+                      <a:r>
+                        <a:rPr lang="fr-FR" dirty="0" err="1" smtClean="0"/>
+                        <a:t>Tested</a:t>
+                      </a:r>
+                      <a:r>
+                        <a:rPr lang="fr-FR" dirty="0" smtClean="0"/>
+                        <a:t> </a:t>
+                      </a:r>
+                      <a:r>
+                        <a:rPr lang="fr-FR" dirty="0" err="1" smtClean="0"/>
+                        <a:t>with</a:t>
+                      </a:r>
+                      <a:r>
+                        <a:rPr lang="fr-FR" dirty="0" smtClean="0"/>
+                        <a:t> </a:t>
+                      </a:r>
+                      <a:r>
+                        <a:rPr lang="fr-FR" dirty="0" err="1" smtClean="0"/>
+                        <a:t>theory</a:t>
+                      </a:r>
+                      <a:r>
+                        <a:rPr lang="fr-FR" dirty="0" smtClean="0"/>
+                        <a:t> by </a:t>
+                      </a:r>
+                      <a:r>
+                        <a:rPr lang="fr-FR" dirty="0" err="1" smtClean="0"/>
+                        <a:t>characterising</a:t>
+                      </a:r>
+                      <a:r>
+                        <a:rPr lang="fr-FR" baseline="0" dirty="0" smtClean="0"/>
+                        <a:t> the robot</a:t>
+                      </a:r>
+                    </a:p>
+                  </a:txBody>
+                  <a:tcPr/>
+                </a:tc>
+              </a:tr>
+              <a:tr h="370840">
+                <a:tc vMerge="1">
+                  <a:txBody>
+                    <a:bodyPr/>
+                    <a:lstStyle/>
+                    <a:p>
+                      <a:endParaRPr lang="fr-FR" dirty="0"/>
+                    </a:p>
+                  </a:txBody>
+                  <a:tcPr/>
+                </a:tc>
+                <a:tc>
+                  <a:txBody>
+                    <a:bodyPr/>
+                    <a:lstStyle/>
+                    <a:p>
+                      <a:endParaRPr lang="fr-FR" dirty="0"/>
+                    </a:p>
+                  </a:txBody>
+                  <a:tcPr/>
+                </a:tc>
+                <a:tc>
+                  <a:txBody>
+                    <a:bodyPr/>
+                    <a:lstStyle/>
+                    <a:p>
+                      <a:r>
+                        <a:rPr lang="fr-FR" dirty="0" err="1" smtClean="0"/>
+                        <a:t>Snipping</a:t>
+                      </a:r>
+                      <a:r>
+                        <a:rPr lang="fr-FR" dirty="0" smtClean="0"/>
+                        <a:t> </a:t>
+                      </a:r>
+                      <a:r>
+                        <a:rPr lang="fr-FR" dirty="0" err="1" smtClean="0"/>
+                        <a:t>tool</a:t>
+                      </a:r>
+                      <a:r>
+                        <a:rPr lang="fr-FR" dirty="0" smtClean="0"/>
+                        <a:t> of the </a:t>
+                      </a:r>
+                      <a:r>
+                        <a:rPr lang="fr-FR" dirty="0" err="1" smtClean="0"/>
+                        <a:t>telemetry</a:t>
+                      </a:r>
+                      <a:r>
+                        <a:rPr lang="fr-FR" dirty="0" smtClean="0"/>
+                        <a:t> of the angle and </a:t>
+                      </a:r>
+                      <a:r>
+                        <a:rPr lang="fr-FR" dirty="0" err="1" smtClean="0"/>
+                        <a:t>immediatly</a:t>
+                      </a:r>
+                      <a:r>
+                        <a:rPr lang="fr-FR" dirty="0" smtClean="0"/>
+                        <a:t> </a:t>
+                      </a:r>
+                      <a:r>
+                        <a:rPr lang="fr-FR" dirty="0" err="1" smtClean="0"/>
+                        <a:t>spotted</a:t>
+                      </a:r>
+                      <a:r>
+                        <a:rPr lang="fr-FR" dirty="0" smtClean="0"/>
+                        <a:t> an</a:t>
+                      </a:r>
+                      <a:r>
+                        <a:rPr lang="fr-FR" baseline="0" dirty="0" smtClean="0"/>
+                        <a:t> </a:t>
+                      </a:r>
+                      <a:r>
+                        <a:rPr lang="fr-FR" baseline="0" dirty="0" err="1" smtClean="0"/>
+                        <a:t>erroneous</a:t>
+                      </a:r>
+                      <a:r>
+                        <a:rPr lang="fr-FR" baseline="0" dirty="0" smtClean="0"/>
+                        <a:t> </a:t>
+                      </a:r>
+                      <a:r>
+                        <a:rPr lang="fr-FR" baseline="0" dirty="0" err="1" smtClean="0"/>
+                        <a:t>sign</a:t>
+                      </a:r>
+                      <a:r>
+                        <a:rPr lang="fr-FR" baseline="0" dirty="0" smtClean="0"/>
+                        <a:t> and </a:t>
+                      </a:r>
+                      <a:r>
+                        <a:rPr lang="fr-FR" baseline="0" dirty="0" err="1" smtClean="0"/>
+                        <a:t>solve</a:t>
+                      </a:r>
+                      <a:r>
+                        <a:rPr lang="fr-FR" baseline="0" dirty="0" smtClean="0"/>
+                        <a:t> </a:t>
+                      </a:r>
+                      <a:r>
+                        <a:rPr lang="fr-FR" baseline="0" dirty="0" err="1" smtClean="0"/>
+                        <a:t>it</a:t>
+                      </a:r>
+                      <a:endParaRPr lang="fr-FR" dirty="0"/>
+                    </a:p>
+                  </a:txBody>
+                  <a:tcPr/>
+                </a:tc>
+              </a:tr>
+            </a:tbl>
+          </a:graphicData>
+        </a:graphic>
+      </p:graphicFrame>
+    </p:spTree>
+  </p:cSld>
+  <p:clrMapOvr>
+    <a:masterClrMapping/>
+  </p:clrMapOvr>
+</p:sld>
+</file>
+
+<file path=ppt/slides/slide3.xml><?xml version="1.0" encoding="utf-8"?>
+<p:sld xmlns:a="http://schemas.openxmlformats.org/drawingml/2006/main" xmlns:r="http://schemas.openxmlformats.org/officeDocument/2006/relationships" xmlns:p="http://schemas.openxmlformats.org/presentationml/2006/main">
+  <p:cSld>
+    <p:spTree>
+      <p:nvGrpSpPr>
+        <p:cNvPr id="1" name=""/>
+        <p:cNvGrpSpPr/>
+        <p:nvPr/>
+      </p:nvGrpSpPr>
+      <p:grpSpPr>
+        <a:xfrm>
+          <a:off x="0" y="0"/>
+          <a:ext cx="0" cy="0"/>
+          <a:chOff x="0" y="0"/>
+          <a:chExt cx="0" cy="0"/>
+        </a:xfrm>
+      </p:grpSpPr>
+      <p:sp>
+        <p:nvSpPr>
+          <p:cNvPr id="2" name="Titre 1"/>
+          <p:cNvSpPr>
+            <a:spLocks noGrp="1"/>
+          </p:cNvSpPr>
+          <p:nvPr>
+            <p:ph type="title"/>
+          </p:nvPr>
+        </p:nvSpPr>
+        <p:spPr/>
+        <p:txBody>
+          <a:bodyPr/>
+          <a:lstStyle/>
+          <a:p>
+            <a:r>
+              <a:rPr lang="fr-FR" dirty="0" smtClean="0"/>
+              <a:t>MCP</a:t>
+            </a:r>
+            <a:endParaRPr lang="fr-FR" dirty="0"/>
+          </a:p>
+        </p:txBody>
+      </p:sp>
+      <p:sp>
+        <p:nvSpPr>
+          <p:cNvPr id="3" name="Espace réservé du contenu 2"/>
+          <p:cNvSpPr>
+            <a:spLocks noGrp="1"/>
+          </p:cNvSpPr>
+          <p:nvPr>
+            <p:ph idx="1"/>
+          </p:nvPr>
+        </p:nvSpPr>
+        <p:spPr/>
+        <p:txBody>
+          <a:bodyPr/>
+          <a:lstStyle/>
+          <a:p>
+            <a:r>
+              <a:rPr lang="fr-FR" dirty="0" err="1" smtClean="0"/>
+              <a:t>Created</a:t>
+            </a:r>
+            <a:r>
+              <a:rPr lang="fr-FR" dirty="0" smtClean="0"/>
+              <a:t> a MCP to </a:t>
+            </a:r>
+            <a:r>
+              <a:rPr lang="fr-FR" dirty="0" err="1" smtClean="0"/>
+              <a:t>give</a:t>
+            </a:r>
+            <a:r>
+              <a:rPr lang="fr-FR" dirty="0" smtClean="0"/>
+              <a:t> </a:t>
+            </a:r>
+            <a:r>
+              <a:rPr lang="fr-FR" dirty="0" err="1" smtClean="0"/>
+              <a:t>access</a:t>
+            </a:r>
+            <a:r>
+              <a:rPr lang="fr-FR" dirty="0" smtClean="0"/>
+              <a:t> to Claude </a:t>
+            </a:r>
+            <a:r>
+              <a:rPr lang="fr-FR" dirty="0" err="1" smtClean="0"/>
+              <a:t>directly</a:t>
+            </a:r>
+            <a:r>
+              <a:rPr lang="fr-FR" dirty="0" smtClean="0"/>
+              <a:t> the full control of the robot.</a:t>
+            </a:r>
+          </a:p>
+          <a:p>
+            <a:r>
+              <a:rPr lang="fr-FR" dirty="0" smtClean="0"/>
+              <a:t>Good: </a:t>
+            </a:r>
+            <a:r>
+              <a:rPr lang="fr-FR" dirty="0" err="1" smtClean="0"/>
+              <a:t>can</a:t>
+            </a:r>
+            <a:r>
+              <a:rPr lang="fr-FR" dirty="0" smtClean="0"/>
+              <a:t> set </a:t>
+            </a:r>
+            <a:r>
+              <a:rPr lang="fr-FR" dirty="0" err="1" smtClean="0"/>
+              <a:t>any</a:t>
+            </a:r>
+            <a:r>
+              <a:rPr lang="fr-FR" dirty="0" smtClean="0"/>
+              <a:t> </a:t>
+            </a:r>
+            <a:r>
+              <a:rPr lang="fr-FR" dirty="0" err="1" smtClean="0"/>
+              <a:t>parameter</a:t>
+            </a:r>
+            <a:endParaRPr lang="fr-FR" dirty="0" smtClean="0"/>
+          </a:p>
+          <a:p>
+            <a:r>
+              <a:rPr lang="fr-FR" dirty="0" smtClean="0"/>
+              <a:t>Not So Good: as </a:t>
+            </a:r>
+            <a:r>
+              <a:rPr lang="fr-FR" dirty="0" err="1" smtClean="0"/>
+              <a:t>he</a:t>
+            </a:r>
+            <a:r>
+              <a:rPr lang="fr-FR" dirty="0" smtClean="0"/>
+              <a:t> </a:t>
+            </a:r>
+            <a:r>
+              <a:rPr lang="fr-FR" dirty="0" err="1" smtClean="0"/>
+              <a:t>think</a:t>
+            </a:r>
+            <a:r>
+              <a:rPr lang="fr-FR" dirty="0" smtClean="0"/>
+              <a:t> a lot, </a:t>
+            </a:r>
+            <a:r>
+              <a:rPr lang="fr-FR" dirty="0" err="1" smtClean="0"/>
+              <a:t>he</a:t>
+            </a:r>
+            <a:r>
+              <a:rPr lang="fr-FR" dirty="0" smtClean="0"/>
+              <a:t> </a:t>
+            </a:r>
+            <a:r>
+              <a:rPr lang="fr-FR" dirty="0" err="1" smtClean="0"/>
+              <a:t>thinks</a:t>
+            </a:r>
+            <a:r>
+              <a:rPr lang="fr-FR" dirty="0" smtClean="0"/>
+              <a:t> </a:t>
+            </a:r>
+            <a:r>
+              <a:rPr lang="fr-FR" dirty="0" err="1" smtClean="0"/>
+              <a:t>after</a:t>
+            </a:r>
+            <a:r>
+              <a:rPr lang="fr-FR" dirty="0" smtClean="0"/>
+              <a:t> </a:t>
+            </a:r>
+            <a:r>
+              <a:rPr lang="fr-FR" dirty="0" err="1" smtClean="0"/>
+              <a:t>each</a:t>
+            </a:r>
+            <a:r>
+              <a:rPr lang="fr-FR" dirty="0" smtClean="0"/>
+              <a:t> action </a:t>
+            </a:r>
+            <a:r>
+              <a:rPr lang="fr-FR" dirty="0" err="1" smtClean="0"/>
+              <a:t>he</a:t>
+            </a:r>
+            <a:r>
+              <a:rPr lang="fr-FR" dirty="0" smtClean="0"/>
+              <a:t> do </a:t>
+            </a:r>
+            <a:r>
+              <a:rPr lang="fr-FR" dirty="0" err="1" smtClean="0"/>
+              <a:t>slowing</a:t>
+            </a:r>
+            <a:r>
+              <a:rPr lang="fr-FR" dirty="0" smtClean="0"/>
+              <a:t> down the </a:t>
+            </a:r>
+            <a:r>
+              <a:rPr lang="fr-FR" dirty="0" err="1" smtClean="0"/>
+              <a:t>process</a:t>
+            </a:r>
+            <a:r>
+              <a:rPr lang="fr-FR" smtClean="0"/>
+              <a:t> a lot.</a:t>
+            </a:r>
+            <a:endParaRPr lang="fr-FR"/>
+          </a:p>
+        </p:txBody>
+      </p:sp>
+    </p:spTree>
+  </p:cSld>
+  <p:clrMapOvr>
+    <a:masterClrMapping/>
+  </p:clrMapOvr>
+</p:sld>
+</file>
+
+<file path=ppt/slides/slide4.xml><?xml version="1.0" encoding="utf-8"?>
+<p:sld xmlns:a="http://schemas.openxmlformats.org/drawingml/2006/main" xmlns:r="http://schemas.openxmlformats.org/officeDocument/2006/relationships" xmlns:p="http://schemas.openxmlformats.org/presentationml/2006/main">
+  <p:cSld>
+    <p:spTree>
+      <p:nvGrpSpPr>
+        <p:cNvPr id="1" name=""/>
+        <p:cNvGrpSpPr/>
+        <p:nvPr/>
+      </p:nvGrpSpPr>
+      <p:grpSpPr>
+        <a:xfrm>
+          <a:off x="0" y="0"/>
+          <a:ext cx="0" cy="0"/>
+          <a:chOff x="0" y="0"/>
+          <a:chExt cx="0" cy="0"/>
+        </a:xfrm>
+      </p:grpSpPr>
+      <p:pic>
+        <p:nvPicPr>
+          <p:cNvPr id="1026" name="Picture 2"/>
+          <p:cNvPicPr>
+            <a:picLocks noChangeAspect="1" noChangeArrowheads="1"/>
+          </p:cNvPicPr>
+          <p:nvPr/>
+        </p:nvPicPr>
+        <p:blipFill>
+          <a:blip r:embed="rId2" cstate="print"/>
+          <a:srcRect/>
+          <a:stretch>
+            <a:fillRect/>
+          </a:stretch>
+        </p:blipFill>
+        <p:spPr bwMode="auto">
+          <a:xfrm>
+            <a:off x="-213348" y="980728"/>
+            <a:ext cx="9753900" cy="4991892"/>
+          </a:xfrm>
+          <a:prstGeom prst="rect">
+            <a:avLst/>
+          </a:prstGeom>
+          <a:noFill/>
+          <a:ln w="9525">
+            <a:noFill/>
+            <a:miter lim="800000"/>
+            <a:headEnd/>
+            <a:tailEnd/>
+          </a:ln>
+          <a:effectLst/>
+        </p:spPr>
+      </p:pic>
+    </p:spTree>
+  </p:cSld>
+  <p:clrMapOvr>
+    <a:masterClrMapping/>
+  </p:clrMapOvr>
+</p:sld>
+</file>
+
+<file path=ppt/slides/slide5.xml><?xml version="1.0" encoding="utf-8"?>
+<p:sld xmlns:a="http://schemas.openxmlformats.org/drawingml/2006/main" xmlns:r="http://schemas.openxmlformats.org/officeDocument/2006/relationships" xmlns:p="http://schemas.openxmlformats.org/presentationml/2006/main">
+  <p:cSld>
+    <p:spTree>
+      <p:nvGrpSpPr>
+        <p:cNvPr id="1" name=""/>
+        <p:cNvGrpSpPr/>
+        <p:nvPr/>
+      </p:nvGrpSpPr>
+      <p:grpSpPr>
+        <a:xfrm>
+          <a:off x="0" y="0"/>
+          <a:ext cx="0" cy="0"/>
+          <a:chOff x="0" y="0"/>
+          <a:chExt cx="0" cy="0"/>
+        </a:xfrm>
+      </p:grpSpPr>
+      <p:pic>
+        <p:nvPicPr>
+          <p:cNvPr id="2050" name="Picture 2"/>
+          <p:cNvPicPr>
+            <a:picLocks noChangeAspect="1" noChangeArrowheads="1"/>
+          </p:cNvPicPr>
+          <p:nvPr/>
+        </p:nvPicPr>
+        <p:blipFill>
+          <a:blip r:embed="rId2" cstate="print"/>
+          <a:srcRect/>
+          <a:stretch>
+            <a:fillRect/>
+          </a:stretch>
+        </p:blipFill>
+        <p:spPr bwMode="auto">
+          <a:xfrm>
+            <a:off x="0" y="0"/>
+            <a:ext cx="1800200" cy="3469692"/>
+          </a:xfrm>
+          <a:prstGeom prst="rect">
+            <a:avLst/>
+          </a:prstGeom>
+          <a:noFill/>
+          <a:ln w="9525">
+            <a:noFill/>
+            <a:miter lim="800000"/>
+            <a:headEnd/>
+            <a:tailEnd/>
+          </a:ln>
+          <a:effectLst/>
+        </p:spPr>
+      </p:pic>
+      <p:pic>
+        <p:nvPicPr>
+          <p:cNvPr id="2051" name="Picture 3"/>
+          <p:cNvPicPr>
+            <a:picLocks noChangeAspect="1" noChangeArrowheads="1"/>
+          </p:cNvPicPr>
+          <p:nvPr/>
+        </p:nvPicPr>
+        <p:blipFill>
+          <a:blip r:embed="rId3" cstate="print"/>
+          <a:srcRect/>
+          <a:stretch>
+            <a:fillRect/>
+          </a:stretch>
+        </p:blipFill>
+        <p:spPr bwMode="auto">
+          <a:xfrm>
+            <a:off x="1835696" y="0"/>
+            <a:ext cx="1564680" cy="3642990"/>
+          </a:xfrm>
+          <a:prstGeom prst="rect">
+            <a:avLst/>
+          </a:prstGeom>
+          <a:noFill/>
+          <a:ln w="9525">
+            <a:noFill/>
+            <a:miter lim="800000"/>
+            <a:headEnd/>
+            <a:tailEnd/>
+          </a:ln>
+          <a:effectLst/>
+        </p:spPr>
+      </p:pic>
+      <p:pic>
+        <p:nvPicPr>
+          <p:cNvPr id="2052" name="Picture 4"/>
+          <p:cNvPicPr>
+            <a:picLocks noChangeAspect="1" noChangeArrowheads="1"/>
+          </p:cNvPicPr>
+          <p:nvPr/>
+        </p:nvPicPr>
+        <p:blipFill>
+          <a:blip r:embed="rId4" cstate="print"/>
+          <a:srcRect/>
+          <a:stretch>
+            <a:fillRect/>
+          </a:stretch>
+        </p:blipFill>
+        <p:spPr bwMode="auto">
+          <a:xfrm>
+            <a:off x="3491880" y="0"/>
+            <a:ext cx="1596578" cy="3623272"/>
+          </a:xfrm>
+          <a:prstGeom prst="rect">
+            <a:avLst/>
+          </a:prstGeom>
+          <a:noFill/>
+          <a:ln w="9525">
+            <a:noFill/>
+            <a:miter lim="800000"/>
+            <a:headEnd/>
+            <a:tailEnd/>
+          </a:ln>
+          <a:effectLst/>
+        </p:spPr>
+      </p:pic>
+      <p:pic>
+        <p:nvPicPr>
+          <p:cNvPr id="2053" name="Picture 5"/>
+          <p:cNvPicPr>
+            <a:picLocks noChangeAspect="1" noChangeArrowheads="1"/>
+          </p:cNvPicPr>
+          <p:nvPr/>
+        </p:nvPicPr>
+        <p:blipFill>
+          <a:blip r:embed="rId5" cstate="print"/>
+          <a:srcRect/>
+          <a:stretch>
+            <a:fillRect/>
+          </a:stretch>
+        </p:blipFill>
+        <p:spPr bwMode="auto">
+          <a:xfrm>
+            <a:off x="5148064" y="0"/>
+            <a:ext cx="1520722" cy="3573016"/>
+          </a:xfrm>
+          <a:prstGeom prst="rect">
+            <a:avLst/>
+          </a:prstGeom>
+          <a:noFill/>
+          <a:ln w="9525">
+            <a:noFill/>
+            <a:miter lim="800000"/>
+            <a:headEnd/>
+            <a:tailEnd/>
+          </a:ln>
+          <a:effectLst/>
+        </p:spPr>
+      </p:pic>
+    </p:spTree>
+  </p:cSld>
+  <p:clrMapOvr>
+    <a:masterClrMapping/>
+  </p:clrMapOvr>
+</p:sld>
+</file>
+
+<file path=ppt/slides/slide6.xml><?xml version="1.0" encoding="utf-8"?>
+<p:sld xmlns:a="http://schemas.openxmlformats.org/drawingml/2006/main" xmlns:r="http://schemas.openxmlformats.org/officeDocument/2006/relationships" xmlns:p="http://schemas.openxmlformats.org/presentationml/2006/main">
+  <p:cSld>
+    <p:spTree>
+      <p:nvGrpSpPr>
+        <p:cNvPr id="1" name=""/>
+        <p:cNvGrpSpPr/>
+        <p:nvPr/>
+      </p:nvGrpSpPr>
+      <p:grpSpPr>
+        <a:xfrm>
+          <a:off x="0" y="0"/>
+          <a:ext cx="0" cy="0"/>
+          <a:chOff x="0" y="0"/>
+          <a:chExt cx="0" cy="0"/>
+        </a:xfrm>
+      </p:grpSpPr>
+      <p:pic>
+        <p:nvPicPr>
+          <p:cNvPr id="3074" name="Picture 2"/>
+          <p:cNvPicPr>
+            <a:picLocks noChangeAspect="1" noChangeArrowheads="1"/>
+          </p:cNvPicPr>
+          <p:nvPr/>
+        </p:nvPicPr>
+        <p:blipFill>
+          <a:blip r:embed="rId2" cstate="print"/>
+          <a:srcRect/>
+          <a:stretch>
+            <a:fillRect/>
+          </a:stretch>
+        </p:blipFill>
+        <p:spPr bwMode="auto">
+          <a:xfrm>
+            <a:off x="323528" y="476672"/>
+            <a:ext cx="8435826" cy="4710584"/>
+          </a:xfrm>
+          <a:prstGeom prst="rect">
+            <a:avLst/>
+          </a:prstGeom>
+          <a:noFill/>
+          <a:ln w="9525">
+            <a:noFill/>
+            <a:miter lim="800000"/>
+            <a:headEnd/>
+            <a:tailEnd/>
+          </a:ln>
+          <a:effectLst/>
+        </p:spPr>
+      </p:pic>
+    </p:spTree>
+  </p:cSld>
+  <p:clrMapOvr>
+    <a:masterClrMapping/>
+  </p:clrMapOvr>
+</p:sld>
 </file>
 
 <file path=ppt/theme/theme1.xml><?xml version="1.0" encoding="utf-8"?>

</xml_diff>

<commit_message>
Step 1 advertising ok
</commit_message>
<xml_diff>
--- a/gen_ai_robot_pendulum.pptx
+++ b/gen_ai_robot_pendulum.pptx
@@ -11,6 +11,8 @@
     <p:sldId id="259" r:id="rId5"/>
     <p:sldId id="260" r:id="rId6"/>
     <p:sldId id="261" r:id="rId7"/>
+    <p:sldId id="262" r:id="rId8"/>
+    <p:sldId id="263" r:id="rId9"/>
   </p:sldIdLst>
   <p:sldSz cx="9144000" cy="6858000" type="screen4x3"/>
   <p:notesSz cx="6858000" cy="9144000"/>
@@ -294,7 +296,7 @@
             <a:fld id="{AA309A6D-C09C-4548-B29A-6CF363A7E532}" type="datetimeFigureOut">
               <a:rPr lang="fr-FR" smtClean="0"/>
               <a:pPr/>
-              <a:t>16/06/2026</a:t>
+              <a:t>23/06/2026</a:t>
             </a:fld>
             <a:endParaRPr lang="fr-BE"/>
           </a:p>
@@ -461,7 +463,7 @@
             <a:fld id="{AA309A6D-C09C-4548-B29A-6CF363A7E532}" type="datetimeFigureOut">
               <a:rPr lang="fr-FR" smtClean="0"/>
               <a:pPr/>
-              <a:t>16/06/2026</a:t>
+              <a:t>23/06/2026</a:t>
             </a:fld>
             <a:endParaRPr lang="fr-BE"/>
           </a:p>
@@ -638,7 +640,7 @@
             <a:fld id="{AA309A6D-C09C-4548-B29A-6CF363A7E532}" type="datetimeFigureOut">
               <a:rPr lang="fr-FR" smtClean="0"/>
               <a:pPr/>
-              <a:t>16/06/2026</a:t>
+              <a:t>23/06/2026</a:t>
             </a:fld>
             <a:endParaRPr lang="fr-BE"/>
           </a:p>
@@ -805,7 +807,7 @@
             <a:fld id="{AA309A6D-C09C-4548-B29A-6CF363A7E532}" type="datetimeFigureOut">
               <a:rPr lang="fr-FR" smtClean="0"/>
               <a:pPr/>
-              <a:t>16/06/2026</a:t>
+              <a:t>23/06/2026</a:t>
             </a:fld>
             <a:endParaRPr lang="fr-BE"/>
           </a:p>
@@ -1048,7 +1050,7 @@
             <a:fld id="{AA309A6D-C09C-4548-B29A-6CF363A7E532}" type="datetimeFigureOut">
               <a:rPr lang="fr-FR" smtClean="0"/>
               <a:pPr/>
-              <a:t>16/06/2026</a:t>
+              <a:t>23/06/2026</a:t>
             </a:fld>
             <a:endParaRPr lang="fr-BE"/>
           </a:p>
@@ -1333,7 +1335,7 @@
             <a:fld id="{AA309A6D-C09C-4548-B29A-6CF363A7E532}" type="datetimeFigureOut">
               <a:rPr lang="fr-FR" smtClean="0"/>
               <a:pPr/>
-              <a:t>16/06/2026</a:t>
+              <a:t>23/06/2026</a:t>
             </a:fld>
             <a:endParaRPr lang="fr-BE"/>
           </a:p>
@@ -1752,7 +1754,7 @@
             <a:fld id="{AA309A6D-C09C-4548-B29A-6CF363A7E532}" type="datetimeFigureOut">
               <a:rPr lang="fr-FR" smtClean="0"/>
               <a:pPr/>
-              <a:t>16/06/2026</a:t>
+              <a:t>23/06/2026</a:t>
             </a:fld>
             <a:endParaRPr lang="fr-BE"/>
           </a:p>
@@ -1867,7 +1869,7 @@
             <a:fld id="{AA309A6D-C09C-4548-B29A-6CF363A7E532}" type="datetimeFigureOut">
               <a:rPr lang="fr-FR" smtClean="0"/>
               <a:pPr/>
-              <a:t>16/06/2026</a:t>
+              <a:t>23/06/2026</a:t>
             </a:fld>
             <a:endParaRPr lang="fr-BE"/>
           </a:p>
@@ -1959,7 +1961,7 @@
             <a:fld id="{AA309A6D-C09C-4548-B29A-6CF363A7E532}" type="datetimeFigureOut">
               <a:rPr lang="fr-FR" smtClean="0"/>
               <a:pPr/>
-              <a:t>16/06/2026</a:t>
+              <a:t>23/06/2026</a:t>
             </a:fld>
             <a:endParaRPr lang="fr-BE"/>
           </a:p>
@@ -2233,7 +2235,7 @@
             <a:fld id="{AA309A6D-C09C-4548-B29A-6CF363A7E532}" type="datetimeFigureOut">
               <a:rPr lang="fr-FR" smtClean="0"/>
               <a:pPr/>
-              <a:t>16/06/2026</a:t>
+              <a:t>23/06/2026</a:t>
             </a:fld>
             <a:endParaRPr lang="fr-BE"/>
           </a:p>
@@ -2483,7 +2485,7 @@
             <a:fld id="{AA309A6D-C09C-4548-B29A-6CF363A7E532}" type="datetimeFigureOut">
               <a:rPr lang="fr-FR" smtClean="0"/>
               <a:pPr/>
-              <a:t>16/06/2026</a:t>
+              <a:t>23/06/2026</a:t>
             </a:fld>
             <a:endParaRPr lang="fr-BE"/>
           </a:p>
@@ -2693,7 +2695,7 @@
             <a:fld id="{AA309A6D-C09C-4548-B29A-6CF363A7E532}" type="datetimeFigureOut">
               <a:rPr lang="fr-FR" smtClean="0"/>
               <a:pPr/>
-              <a:t>16/06/2026</a:t>
+              <a:t>23/06/2026</a:t>
             </a:fld>
             <a:endParaRPr lang="fr-BE"/>
           </a:p>
@@ -5348,6 +5350,240 @@
           <a:xfrm>
             <a:off x="323528" y="476672"/>
             <a:ext cx="8435826" cy="4710584"/>
+          </a:xfrm>
+          <a:prstGeom prst="rect">
+            <a:avLst/>
+          </a:prstGeom>
+          <a:noFill/>
+          <a:ln w="9525">
+            <a:noFill/>
+            <a:miter lim="800000"/>
+            <a:headEnd/>
+            <a:tailEnd/>
+          </a:ln>
+          <a:effectLst/>
+        </p:spPr>
+      </p:pic>
+    </p:spTree>
+  </p:cSld>
+  <p:clrMapOvr>
+    <a:masterClrMapping/>
+  </p:clrMapOvr>
+</p:sld>
+</file>
+
+<file path=ppt/slides/slide7.xml><?xml version="1.0" encoding="utf-8"?>
+<p:sld xmlns:a="http://schemas.openxmlformats.org/drawingml/2006/main" xmlns:r="http://schemas.openxmlformats.org/officeDocument/2006/relationships" xmlns:p="http://schemas.openxmlformats.org/presentationml/2006/main">
+  <p:cSld>
+    <p:spTree>
+      <p:nvGrpSpPr>
+        <p:cNvPr id="1" name=""/>
+        <p:cNvGrpSpPr/>
+        <p:nvPr/>
+      </p:nvGrpSpPr>
+      <p:grpSpPr>
+        <a:xfrm>
+          <a:off x="0" y="0"/>
+          <a:ext cx="0" cy="0"/>
+          <a:chOff x="0" y="0"/>
+          <a:chExt cx="0" cy="0"/>
+        </a:xfrm>
+      </p:grpSpPr>
+      <p:sp>
+        <p:nvSpPr>
+          <p:cNvPr id="2" name="Titre 1"/>
+          <p:cNvSpPr>
+            <a:spLocks noGrp="1"/>
+          </p:cNvSpPr>
+          <p:nvPr>
+            <p:ph type="title"/>
+          </p:nvPr>
+        </p:nvSpPr>
+        <p:spPr/>
+        <p:txBody>
+          <a:bodyPr/>
+          <a:lstStyle/>
+          <a:p>
+            <a:endParaRPr lang="fr-FR"/>
+          </a:p>
+        </p:txBody>
+      </p:sp>
+      <p:pic>
+        <p:nvPicPr>
+          <p:cNvPr id="1026" name="Picture 2"/>
+          <p:cNvPicPr>
+            <a:picLocks noChangeAspect="1" noChangeArrowheads="1"/>
+          </p:cNvPicPr>
+          <p:nvPr/>
+        </p:nvPicPr>
+        <p:blipFill>
+          <a:blip r:embed="rId2" cstate="print"/>
+          <a:srcRect/>
+          <a:stretch>
+            <a:fillRect/>
+          </a:stretch>
+        </p:blipFill>
+        <p:spPr bwMode="auto">
+          <a:xfrm>
+            <a:off x="0" y="1628800"/>
+            <a:ext cx="5314950" cy="2152650"/>
+          </a:xfrm>
+          <a:prstGeom prst="rect">
+            <a:avLst/>
+          </a:prstGeom>
+          <a:noFill/>
+          <a:ln w="9525">
+            <a:noFill/>
+            <a:miter lim="800000"/>
+            <a:headEnd/>
+            <a:tailEnd/>
+          </a:ln>
+          <a:effectLst/>
+        </p:spPr>
+      </p:pic>
+      <p:pic>
+        <p:nvPicPr>
+          <p:cNvPr id="1027" name="Picture 3"/>
+          <p:cNvPicPr>
+            <a:picLocks noChangeAspect="1" noChangeArrowheads="1"/>
+          </p:cNvPicPr>
+          <p:nvPr/>
+        </p:nvPicPr>
+        <p:blipFill>
+          <a:blip r:embed="rId3" cstate="print"/>
+          <a:srcRect/>
+          <a:stretch>
+            <a:fillRect/>
+          </a:stretch>
+        </p:blipFill>
+        <p:spPr bwMode="auto">
+          <a:xfrm>
+            <a:off x="1259632" y="4365104"/>
+            <a:ext cx="5610225" cy="819150"/>
+          </a:xfrm>
+          <a:prstGeom prst="rect">
+            <a:avLst/>
+          </a:prstGeom>
+          <a:noFill/>
+          <a:ln w="9525">
+            <a:noFill/>
+            <a:miter lim="800000"/>
+            <a:headEnd/>
+            <a:tailEnd/>
+          </a:ln>
+          <a:effectLst/>
+        </p:spPr>
+      </p:pic>
+    </p:spTree>
+  </p:cSld>
+  <p:clrMapOvr>
+    <a:masterClrMapping/>
+  </p:clrMapOvr>
+</p:sld>
+</file>
+
+<file path=ppt/slides/slide8.xml><?xml version="1.0" encoding="utf-8"?>
+<p:sld xmlns:a="http://schemas.openxmlformats.org/drawingml/2006/main" xmlns:r="http://schemas.openxmlformats.org/officeDocument/2006/relationships" xmlns:p="http://schemas.openxmlformats.org/presentationml/2006/main">
+  <p:cSld>
+    <p:spTree>
+      <p:nvGrpSpPr>
+        <p:cNvPr id="1" name=""/>
+        <p:cNvGrpSpPr/>
+        <p:nvPr/>
+      </p:nvGrpSpPr>
+      <p:grpSpPr>
+        <a:xfrm>
+          <a:off x="0" y="0"/>
+          <a:ext cx="0" cy="0"/>
+          <a:chOff x="0" y="0"/>
+          <a:chExt cx="0" cy="0"/>
+        </a:xfrm>
+      </p:grpSpPr>
+      <p:pic>
+        <p:nvPicPr>
+          <p:cNvPr id="2050" name="Picture 2"/>
+          <p:cNvPicPr>
+            <a:picLocks noChangeAspect="1" noChangeArrowheads="1"/>
+          </p:cNvPicPr>
+          <p:nvPr/>
+        </p:nvPicPr>
+        <p:blipFill>
+          <a:blip r:embed="rId2" cstate="print"/>
+          <a:srcRect/>
+          <a:stretch>
+            <a:fillRect/>
+          </a:stretch>
+        </p:blipFill>
+        <p:spPr bwMode="auto">
+          <a:xfrm>
+            <a:off x="0" y="0"/>
+            <a:ext cx="4133850" cy="3171825"/>
+          </a:xfrm>
+          <a:prstGeom prst="rect">
+            <a:avLst/>
+          </a:prstGeom>
+          <a:noFill/>
+          <a:ln w="9525">
+            <a:noFill/>
+            <a:miter lim="800000"/>
+            <a:headEnd/>
+            <a:tailEnd/>
+          </a:ln>
+          <a:effectLst/>
+        </p:spPr>
+      </p:pic>
+      <p:pic>
+        <p:nvPicPr>
+          <p:cNvPr id="2051" name="Picture 3"/>
+          <p:cNvPicPr>
+            <a:picLocks noChangeAspect="1" noChangeArrowheads="1"/>
+          </p:cNvPicPr>
+          <p:nvPr/>
+        </p:nvPicPr>
+        <p:blipFill>
+          <a:blip r:embed="rId3" cstate="print"/>
+          <a:srcRect/>
+          <a:stretch>
+            <a:fillRect/>
+          </a:stretch>
+        </p:blipFill>
+        <p:spPr bwMode="auto">
+          <a:xfrm>
+            <a:off x="395536" y="3140968"/>
+            <a:ext cx="8154987" cy="914400"/>
+          </a:xfrm>
+          <a:prstGeom prst="rect">
+            <a:avLst/>
+          </a:prstGeom>
+          <a:noFill/>
+          <a:ln w="9525">
+            <a:noFill/>
+            <a:miter lim="800000"/>
+            <a:headEnd/>
+            <a:tailEnd/>
+          </a:ln>
+          <a:effectLst/>
+        </p:spPr>
+      </p:pic>
+      <p:pic>
+        <p:nvPicPr>
+          <p:cNvPr id="2052" name="Picture 4"/>
+          <p:cNvPicPr>
+            <a:picLocks noChangeAspect="1" noChangeArrowheads="1"/>
+          </p:cNvPicPr>
+          <p:nvPr/>
+        </p:nvPicPr>
+        <p:blipFill>
+          <a:blip r:embed="rId4" cstate="print"/>
+          <a:srcRect/>
+          <a:stretch>
+            <a:fillRect/>
+          </a:stretch>
+        </p:blipFill>
+        <p:spPr bwMode="auto">
+          <a:xfrm>
+            <a:off x="539552" y="2636912"/>
+            <a:ext cx="8021637" cy="3886200"/>
           </a:xfrm>
           <a:prstGeom prst="rect">
             <a:avLst/>

</xml_diff>

<commit_message>
firmware ble fonctionnel avec telemetrie
</commit_message>
<xml_diff>
--- a/gen_ai_robot_pendulum.pptx
+++ b/gen_ai_robot_pendulum.pptx
@@ -13,6 +13,7 @@
     <p:sldId id="261" r:id="rId7"/>
     <p:sldId id="262" r:id="rId8"/>
     <p:sldId id="263" r:id="rId9"/>
+    <p:sldId id="264" r:id="rId10"/>
   </p:sldIdLst>
   <p:sldSz cx="9144000" cy="6858000" type="screen4x3"/>
   <p:notesSz cx="6858000" cy="9144000"/>
@@ -296,7 +297,7 @@
             <a:fld id="{AA309A6D-C09C-4548-B29A-6CF363A7E532}" type="datetimeFigureOut">
               <a:rPr lang="fr-FR" smtClean="0"/>
               <a:pPr/>
-              <a:t>23/06/2026</a:t>
+              <a:t>24/06/2026</a:t>
             </a:fld>
             <a:endParaRPr lang="fr-BE"/>
           </a:p>
@@ -463,7 +464,7 @@
             <a:fld id="{AA309A6D-C09C-4548-B29A-6CF363A7E532}" type="datetimeFigureOut">
               <a:rPr lang="fr-FR" smtClean="0"/>
               <a:pPr/>
-              <a:t>23/06/2026</a:t>
+              <a:t>24/06/2026</a:t>
             </a:fld>
             <a:endParaRPr lang="fr-BE"/>
           </a:p>
@@ -640,7 +641,7 @@
             <a:fld id="{AA309A6D-C09C-4548-B29A-6CF363A7E532}" type="datetimeFigureOut">
               <a:rPr lang="fr-FR" smtClean="0"/>
               <a:pPr/>
-              <a:t>23/06/2026</a:t>
+              <a:t>24/06/2026</a:t>
             </a:fld>
             <a:endParaRPr lang="fr-BE"/>
           </a:p>
@@ -807,7 +808,7 @@
             <a:fld id="{AA309A6D-C09C-4548-B29A-6CF363A7E532}" type="datetimeFigureOut">
               <a:rPr lang="fr-FR" smtClean="0"/>
               <a:pPr/>
-              <a:t>23/06/2026</a:t>
+              <a:t>24/06/2026</a:t>
             </a:fld>
             <a:endParaRPr lang="fr-BE"/>
           </a:p>
@@ -1050,7 +1051,7 @@
             <a:fld id="{AA309A6D-C09C-4548-B29A-6CF363A7E532}" type="datetimeFigureOut">
               <a:rPr lang="fr-FR" smtClean="0"/>
               <a:pPr/>
-              <a:t>23/06/2026</a:t>
+              <a:t>24/06/2026</a:t>
             </a:fld>
             <a:endParaRPr lang="fr-BE"/>
           </a:p>
@@ -1335,7 +1336,7 @@
             <a:fld id="{AA309A6D-C09C-4548-B29A-6CF363A7E532}" type="datetimeFigureOut">
               <a:rPr lang="fr-FR" smtClean="0"/>
               <a:pPr/>
-              <a:t>23/06/2026</a:t>
+              <a:t>24/06/2026</a:t>
             </a:fld>
             <a:endParaRPr lang="fr-BE"/>
           </a:p>
@@ -1754,7 +1755,7 @@
             <a:fld id="{AA309A6D-C09C-4548-B29A-6CF363A7E532}" type="datetimeFigureOut">
               <a:rPr lang="fr-FR" smtClean="0"/>
               <a:pPr/>
-              <a:t>23/06/2026</a:t>
+              <a:t>24/06/2026</a:t>
             </a:fld>
             <a:endParaRPr lang="fr-BE"/>
           </a:p>
@@ -1869,7 +1870,7 @@
             <a:fld id="{AA309A6D-C09C-4548-B29A-6CF363A7E532}" type="datetimeFigureOut">
               <a:rPr lang="fr-FR" smtClean="0"/>
               <a:pPr/>
-              <a:t>23/06/2026</a:t>
+              <a:t>24/06/2026</a:t>
             </a:fld>
             <a:endParaRPr lang="fr-BE"/>
           </a:p>
@@ -1961,7 +1962,7 @@
             <a:fld id="{AA309A6D-C09C-4548-B29A-6CF363A7E532}" type="datetimeFigureOut">
               <a:rPr lang="fr-FR" smtClean="0"/>
               <a:pPr/>
-              <a:t>23/06/2026</a:t>
+              <a:t>24/06/2026</a:t>
             </a:fld>
             <a:endParaRPr lang="fr-BE"/>
           </a:p>
@@ -2235,7 +2236,7 @@
             <a:fld id="{AA309A6D-C09C-4548-B29A-6CF363A7E532}" type="datetimeFigureOut">
               <a:rPr lang="fr-FR" smtClean="0"/>
               <a:pPr/>
-              <a:t>23/06/2026</a:t>
+              <a:t>24/06/2026</a:t>
             </a:fld>
             <a:endParaRPr lang="fr-BE"/>
           </a:p>
@@ -2485,7 +2486,7 @@
             <a:fld id="{AA309A6D-C09C-4548-B29A-6CF363A7E532}" type="datetimeFigureOut">
               <a:rPr lang="fr-FR" smtClean="0"/>
               <a:pPr/>
-              <a:t>23/06/2026</a:t>
+              <a:t>24/06/2026</a:t>
             </a:fld>
             <a:endParaRPr lang="fr-BE"/>
           </a:p>
@@ -2695,7 +2696,7 @@
             <a:fld id="{AA309A6D-C09C-4548-B29A-6CF363A7E532}" type="datetimeFigureOut">
               <a:rPr lang="fr-FR" smtClean="0"/>
               <a:pPr/>
-              <a:t>23/06/2026</a:t>
+              <a:t>24/06/2026</a:t>
             </a:fld>
             <a:endParaRPr lang="fr-BE"/>
           </a:p>
@@ -5584,6 +5585,130 @@
           <a:xfrm>
             <a:off x="539552" y="2636912"/>
             <a:ext cx="8021637" cy="3886200"/>
+          </a:xfrm>
+          <a:prstGeom prst="rect">
+            <a:avLst/>
+          </a:prstGeom>
+          <a:noFill/>
+          <a:ln w="9525">
+            <a:noFill/>
+            <a:miter lim="800000"/>
+            <a:headEnd/>
+            <a:tailEnd/>
+          </a:ln>
+          <a:effectLst/>
+        </p:spPr>
+      </p:pic>
+    </p:spTree>
+  </p:cSld>
+  <p:clrMapOvr>
+    <a:masterClrMapping/>
+  </p:clrMapOvr>
+</p:sld>
+</file>
+
+<file path=ppt/slides/slide9.xml><?xml version="1.0" encoding="utf-8"?>
+<p:sld xmlns:a="http://schemas.openxmlformats.org/drawingml/2006/main" xmlns:r="http://schemas.openxmlformats.org/officeDocument/2006/relationships" xmlns:p="http://schemas.openxmlformats.org/presentationml/2006/main">
+  <p:cSld>
+    <p:spTree>
+      <p:nvGrpSpPr>
+        <p:cNvPr id="1" name=""/>
+        <p:cNvGrpSpPr/>
+        <p:nvPr/>
+      </p:nvGrpSpPr>
+      <p:grpSpPr>
+        <a:xfrm>
+          <a:off x="0" y="0"/>
+          <a:ext cx="0" cy="0"/>
+          <a:chOff x="0" y="0"/>
+          <a:chExt cx="0" cy="0"/>
+        </a:xfrm>
+      </p:grpSpPr>
+      <p:pic>
+        <p:nvPicPr>
+          <p:cNvPr id="1026" name="Picture 2"/>
+          <p:cNvPicPr>
+            <a:picLocks noChangeAspect="1" noChangeArrowheads="1"/>
+          </p:cNvPicPr>
+          <p:nvPr/>
+        </p:nvPicPr>
+        <p:blipFill>
+          <a:blip r:embed="rId2" cstate="print"/>
+          <a:srcRect/>
+          <a:stretch>
+            <a:fillRect/>
+          </a:stretch>
+        </p:blipFill>
+        <p:spPr bwMode="auto">
+          <a:xfrm>
+            <a:off x="5981700" y="0"/>
+            <a:ext cx="3162300" cy="6983413"/>
+          </a:xfrm>
+          <a:prstGeom prst="rect">
+            <a:avLst/>
+          </a:prstGeom>
+          <a:noFill/>
+          <a:ln w="9525">
+            <a:noFill/>
+            <a:miter lim="800000"/>
+            <a:headEnd/>
+            <a:tailEnd/>
+          </a:ln>
+          <a:effectLst/>
+        </p:spPr>
+      </p:pic>
+      <p:pic>
+        <p:nvPicPr>
+          <p:cNvPr id="1027" name="Picture 3"/>
+          <p:cNvPicPr>
+            <a:picLocks noChangeAspect="1" noChangeArrowheads="1"/>
+          </p:cNvPicPr>
+          <p:nvPr/>
+        </p:nvPicPr>
+        <p:blipFill>
+          <a:blip r:embed="rId3" cstate="print"/>
+          <a:srcRect/>
+          <a:stretch>
+            <a:fillRect/>
+          </a:stretch>
+        </p:blipFill>
+        <p:spPr bwMode="auto">
+          <a:xfrm>
+            <a:off x="0" y="0"/>
+            <a:ext cx="5863010" cy="3839375"/>
+          </a:xfrm>
+          <a:prstGeom prst="rect">
+            <a:avLst/>
+          </a:prstGeom>
+          <a:noFill/>
+          <a:ln w="9525">
+            <a:noFill/>
+            <a:miter lim="800000"/>
+            <a:headEnd/>
+            <a:tailEnd/>
+          </a:ln>
+          <a:effectLst/>
+        </p:spPr>
+      </p:pic>
+      <p:pic>
+        <p:nvPicPr>
+          <p:cNvPr id="1028" name="Picture 4"/>
+          <p:cNvPicPr>
+            <a:picLocks noChangeAspect="1" noChangeArrowheads="1"/>
+          </p:cNvPicPr>
+          <p:nvPr/>
+        </p:nvPicPr>
+        <p:blipFill>
+          <a:blip r:embed="rId4" cstate="print"/>
+          <a:srcRect/>
+          <a:stretch>
+            <a:fillRect/>
+          </a:stretch>
+        </p:blipFill>
+        <p:spPr bwMode="auto">
+          <a:xfrm>
+            <a:off x="539552" y="4149080"/>
+            <a:ext cx="4752528" cy="1529495"/>
           </a:xfrm>
           <a:prstGeom prst="rect">
             <a:avLst/>

</xml_diff>